<commit_message>
Fix fresh-read findings in the deck and documents
Deck: name who approves (the app approves only what owners allow),
complete the never-switched-off list from the charter, keep trade
secrets out of outside AI models, and separate access in the RACI,
with the data team running reviews. Delegates are optional and can
cover several parts, and GPDO is spelled out.

Documents: the name is LEAN Data Governance. The platform owner
approves the AI models agents use. The owner review now covers
operating model changes that add work. The operating model lists
internal controls' tasks, and controls R-08, R-14 and R-18 match the
rules. The README leaves shared data to the owners, and the rulebook
change log records the regrouping.

Co-Authored-By: Claude Opus 5.5 <noreply@anthropic.com>
Claude-Session: https://claude.ai/code/session_01PCy2Xpp9YsL4rxbq6m4G9b
</commit_message>
<xml_diff>
--- a/deck/lean-data-governance.pptx
+++ b/deck/lean-data-governance.pptx
@@ -111,18 +111,18 @@
   <p:extLst>
     <p:ext uri="{521415D9-36F7-43E2-AB2F-B90AF26B5E84}">
       <p14:sectionLst xmlns:p14="http://schemas.microsoft.com/office/powerpoint/2010/main">
-        <p14:section name="Framework" id="{71f384d3-f8c4-59e8-aced-240cfe615d6e}">
+        <p14:section name="Framework" id="{3dbb6ac4-bc74-86e3-28c4-1b2015a637c2}">
           <p14:sldIdLst>
             <p14:sldId id="256"/>
           </p14:sldIdLst>
         </p14:section>
-        <p14:section name="Ownership and rules" id="{3ce2449d-8d01-734f-5751-377f3e7cbed1}">
+        <p14:section name="Ownership and rules" id="{d15ff068-7662-21e7-3538-63adf81c0c1c}">
           <p14:sldIdLst>
             <p14:sldId id="257"/>
             <p14:sldId id="258"/>
           </p14:sldIdLst>
         </p14:section>
-        <p14:section name="Operating model" id="{3966ecd1-d5e9-c2d2-931e-6f16862b2c7e}">
+        <p14:section name="Operating model" id="{93c61eea-a076-f5b8-1f28-c43ada9bdfe8}">
           <p14:sldIdLst>
             <p14:sldId id="259"/>
             <p14:sldId id="260"/>
@@ -620,7 +620,7 @@
           <a:p>
             <a:r>
               <a:rPr lang="en-US" dirty="0"/>
-              <a:t>Ownership sits with the business. Each GPDO owns their domain in every system, SAP or not, and delegates each part to an attribute owner, who sets its rules in the app and decides what the app can’t, or names delegates to. Delegates keep decisions moving, but settings, exceptions, mass changes and access stay with the owner. The platform owner and the data team run the technology and decide nothing about data content, and internal controls checks the data team.</a:t>
+              <a:t>Ownership sits with the business. Each GPDO owns their domain in every system, SAP or not, and delegates each part to an attribute owner, who sets its checks and settings in the app and decides what the app can’t, or names delegates to. Delegates are optional, and one small pool can serve several parts, so a domain needs few people; settings, exceptions, mass changes and access stay with the owner. A sensitive change is one to a field the owner lists as sensitive, such as bank details. The platform owner and the data team run the technology and decide nothing about data content. Internal controls reviews emergency access and any change made without a request.</a:t>
             </a:r>
             <a:endParaRPr lang="en-US" dirty="0"/>
           </a:p>
@@ -796,7 +796,7 @@
           <a:p>
             <a:r>
               <a:rPr lang="en-US" dirty="0"/>
-              <a:t>Who does what, grouped coarsely; the operating model holds the full table. GPDOs set up the domain and stay accountable for all of it. Attribute owners set their part’s rules and can hand the daily cases to delegates. The data team builds and runs the platform under the platform owner, and runs the access reviews. Decisions happen in the app, prompted by agents, so the only standing meeting is the owner review. The first three measures show how little people have to do.</a:t>
+              <a:t>Who does what, grouped coarsely; the operating model holds the full table. GPDOs set up the domain and stay accountable for all of it. Attribute owners set their part’s settings and control access, with the data team running the access reviews. They can hand the daily cases, including the monthly sample of automatic approvals, to delegates. The data team builds and runs the platform under the platform owner. Decisions happen in the app, prompted by agents, so the only standing meeting is the owner review. The first three measures show how little people have to do.</a:t>
             </a:r>
             <a:endParaRPr lang="en-US" dirty="0"/>
           </a:p>
@@ -884,7 +884,7 @@
           <a:p>
             <a:r>
               <a:rPr lang="en-US" dirty="0"/>
-              <a:t>Three systems enforce the rules: the unified app is the front door, SAP is the system of record, and the data platform checks what’s stored and finds changes without a request. Five agents do the coordination and routine work, each for a named audience. They start by proposing for a person to decide, the change reconciler only reports, and they never approve, confirm, delete or grant access.</a:t>
+              <a:t>Three systems enforce the rules: the unified app is the front door, SAP is the system of record, and the data platform checks what’s stored and finds changes without a request. Five agents do the coordination and routine work, each for a named audience. They start by proposing for a person to decide, and the change reconciler only reports. Later, an agent can make routine changes itself where the attribute owner allows, never to sensitive fields, and every change can be reversed. Agents never approve, confirm, delete or grant access, and the platform owner approves the AI models they use.</a:t>
             </a:r>
             <a:endParaRPr lang="en-US" dirty="0"/>
           </a:p>
@@ -1502,11 +1502,11 @@
         <p:spPr>
           <a:xfrm>
             <a:off x="406359" y="807598"/>
-            <a:ext cx="6881409" cy="1528694"/>
+            <a:ext cx="6881409" cy="1330635"/>
           </a:xfrm>
           <a:prstGeom prst="roundRect">
             <a:avLst>
-              <a:gd name="adj" fmla="val 6646"/>
+              <a:gd name="adj" fmla="val 7635"/>
             </a:avLst>
           </a:prstGeom>
           <a:solidFill>
@@ -1523,7 +1523,7 @@
         </p:nvSpPr>
         <p:spPr>
           <a:xfrm>
-            <a:off x="634959" y="1194755"/>
+            <a:off x="634959" y="1095817"/>
             <a:ext cx="6462339" cy="182880"/>
           </a:xfrm>
           <a:prstGeom prst="rect">
@@ -1562,7 +1562,7 @@
         </p:nvSpPr>
         <p:spPr>
           <a:xfrm>
-            <a:off x="634959" y="1453896"/>
+            <a:off x="634959" y="1354866"/>
             <a:ext cx="6462339" cy="495330"/>
           </a:xfrm>
           <a:prstGeom prst="rect">
@@ -1605,11 +1605,11 @@
         <p:spPr>
           <a:xfrm>
             <a:off x="7427488" y="807598"/>
-            <a:ext cx="4358122" cy="1528694"/>
+            <a:ext cx="4358122" cy="1330635"/>
           </a:xfrm>
           <a:prstGeom prst="roundRect">
             <a:avLst>
-              <a:gd name="adj" fmla="val 6646"/>
+              <a:gd name="adj" fmla="val 7635"/>
             </a:avLst>
           </a:prstGeom>
           <a:solidFill>
@@ -1664,7 +1664,7 @@
       </p:sp>
       <p:sp>
         <p:nvSpPr>
-          <p:cNvPr id="10" name="Text: Four domains, one per GPDO: Commercial, "/>
+          <p:cNvPr id="10" name="Text: Four domains, one per GPDO (global proce"/>
           <p:cNvSpPr txBox="1"/>
           <p:nvPr/>
         </p:nvSpPr>
@@ -1709,7 +1709,7 @@
                   <a:schemeClr val="tx1"/>
                 </a:solidFill>
               </a:rPr>
-              <a:t> one per GPDO: Commercial, Manufacturing, Finance and Procurement.</a:t>
+              <a:t> one per GPDO (global process and data owner): Commercial, Manufacturing, Finance and Procurement.</a:t>
             </a:r>
             <a:endParaRPr lang="en-US" sz="1200" dirty="0"/>
           </a:p>
@@ -1770,14 +1770,14 @@
       </p:sp>
       <p:sp>
         <p:nvSpPr>
-          <p:cNvPr id="12" name="Text: Non-SAP and confidential data, such as r"/>
+          <p:cNvPr id="12" name="Text: Non-SAP and confidential data: owned and"/>
           <p:cNvSpPr txBox="1"/>
           <p:nvPr/>
         </p:nvSpPr>
         <p:spPr>
           <a:xfrm>
             <a:off x="7598938" y="1819565"/>
-            <a:ext cx="4053261" cy="396118"/>
+            <a:ext cx="4053261" cy="198059"/>
           </a:xfrm>
           <a:prstGeom prst="rect">
             <a:avLst/>
@@ -1801,7 +1801,7 @@
                   <a:schemeClr val="tx1"/>
                 </a:solidFill>
               </a:rPr>
-              <a:t>Non-SAP and confidential data,</a:t>
+              <a:t>Non-SAP and confidential data:</a:t>
             </a:r>
             <a:pPr algn="l" indent="0" marL="0">
               <a:lnSpc>
@@ -1815,7 +1815,7 @@
                   <a:schemeClr val="tx1"/>
                 </a:solidFill>
               </a:rPr>
-              <a:t> such as recipes: owned and protected now.</a:t>
+              <a:t> owned and protected now.</a:t>
             </a:r>
             <a:endParaRPr lang="en-US" sz="1200" dirty="0"/>
           </a:p>
@@ -1829,7 +1829,7 @@
         </p:nvSpPr>
         <p:spPr>
           <a:xfrm>
-            <a:off x="406359" y="2450592"/>
+            <a:off x="406359" y="2252533"/>
             <a:ext cx="3467130" cy="182880"/>
           </a:xfrm>
           <a:prstGeom prst="rect">
@@ -1868,12 +1868,12 @@
         </p:nvSpPr>
         <p:spPr>
           <a:xfrm>
-            <a:off x="406359" y="2696931"/>
-            <a:ext cx="3429000" cy="561167"/>
+            <a:off x="406359" y="2498964"/>
+            <a:ext cx="3429000" cy="614477"/>
           </a:xfrm>
           <a:prstGeom prst="roundRect">
             <a:avLst>
-              <a:gd name="adj" fmla="val 13579"/>
+              <a:gd name="adj" fmla="val 12401"/>
             </a:avLst>
           </a:prstGeom>
           <a:solidFill>
@@ -1895,7 +1895,7 @@
         </p:nvSpPr>
         <p:spPr>
           <a:xfrm>
-            <a:off x="539770" y="2779502"/>
+            <a:off x="539770" y="2608052"/>
             <a:ext cx="3200400" cy="396118"/>
           </a:xfrm>
           <a:prstGeom prst="rect">
@@ -1948,12 +1948,12 @@
         </p:nvSpPr>
         <p:spPr>
           <a:xfrm>
-            <a:off x="406359" y="3321649"/>
-            <a:ext cx="3429000" cy="561167"/>
+            <a:off x="406359" y="3176900"/>
+            <a:ext cx="3429000" cy="614568"/>
           </a:xfrm>
           <a:prstGeom prst="roundRect">
             <a:avLst>
-              <a:gd name="adj" fmla="val 13579"/>
+              <a:gd name="adj" fmla="val 12399"/>
             </a:avLst>
           </a:prstGeom>
           <a:solidFill>
@@ -1975,7 +1975,7 @@
         </p:nvSpPr>
         <p:spPr>
           <a:xfrm>
-            <a:off x="539770" y="3404220"/>
+            <a:off x="539770" y="3286171"/>
             <a:ext cx="3200400" cy="396118"/>
           </a:xfrm>
           <a:prstGeom prst="rect">
@@ -2028,12 +2028,12 @@
         </p:nvSpPr>
         <p:spPr>
           <a:xfrm>
-            <a:off x="406359" y="3946368"/>
-            <a:ext cx="3429000" cy="561167"/>
+            <a:off x="406359" y="3854928"/>
+            <a:ext cx="3429000" cy="614477"/>
           </a:xfrm>
           <a:prstGeom prst="roundRect">
             <a:avLst>
-              <a:gd name="adj" fmla="val 13579"/>
+              <a:gd name="adj" fmla="val 12401"/>
             </a:avLst>
           </a:prstGeom>
           <a:solidFill>
@@ -2055,7 +2055,7 @@
         </p:nvSpPr>
         <p:spPr>
           <a:xfrm>
-            <a:off x="539770" y="4028846"/>
+            <a:off x="539770" y="3964107"/>
             <a:ext cx="3200400" cy="396118"/>
           </a:xfrm>
           <a:prstGeom prst="rect">
@@ -2108,7 +2108,7 @@
         </p:nvSpPr>
         <p:spPr>
           <a:xfrm>
-            <a:off x="3898910" y="2928823"/>
+            <a:off x="3898910" y="2757465"/>
             <a:ext cx="254020" cy="152430"/>
           </a:xfrm>
           <a:prstGeom prst="rightArrow">
@@ -2128,7 +2128,7 @@
         </p:nvSpPr>
         <p:spPr>
           <a:xfrm>
-            <a:off x="3898910" y="3529767"/>
+            <a:off x="3898910" y="3411718"/>
             <a:ext cx="254020" cy="152430"/>
           </a:xfrm>
           <a:prstGeom prst="rightArrow">
@@ -2148,7 +2148,7 @@
         </p:nvSpPr>
         <p:spPr>
           <a:xfrm>
-            <a:off x="3898910" y="4130802"/>
+            <a:off x="3898910" y="4066062"/>
             <a:ext cx="254020" cy="152430"/>
           </a:xfrm>
           <a:prstGeom prst="rightArrow">
@@ -2168,7 +2168,7 @@
         </p:nvSpPr>
         <p:spPr>
           <a:xfrm>
-            <a:off x="4216390" y="2450592"/>
+            <a:off x="4216390" y="2252533"/>
             <a:ext cx="3594141" cy="182880"/>
           </a:xfrm>
           <a:prstGeom prst="rect">
@@ -2207,12 +2207,12 @@
         </p:nvSpPr>
         <p:spPr>
           <a:xfrm>
-            <a:off x="4216390" y="2696931"/>
-            <a:ext cx="3556010" cy="1810512"/>
+            <a:off x="4216390" y="2498964"/>
+            <a:ext cx="3556010" cy="1970441"/>
           </a:xfrm>
           <a:prstGeom prst="roundRect">
             <a:avLst>
-              <a:gd name="adj" fmla="val 5612"/>
+              <a:gd name="adj" fmla="val 5156"/>
             </a:avLst>
           </a:prstGeom>
           <a:solidFill>
@@ -2229,7 +2229,7 @@
         </p:nvSpPr>
         <p:spPr>
           <a:xfrm>
-            <a:off x="4419570" y="2879171"/>
+            <a:off x="4419570" y="2761031"/>
             <a:ext cx="3187690" cy="476220"/>
           </a:xfrm>
           <a:prstGeom prst="rect">
@@ -2271,7 +2271,7 @@
         </p:nvSpPr>
         <p:spPr>
           <a:xfrm>
-            <a:off x="4419570" y="3444270"/>
+            <a:off x="4419570" y="3326221"/>
             <a:ext cx="3187690" cy="396118"/>
           </a:xfrm>
           <a:prstGeom prst="rect">
@@ -2408,7 +2408,7 @@
         </p:nvSpPr>
         <p:spPr>
           <a:xfrm>
-            <a:off x="4419570" y="3929268"/>
+            <a:off x="4419570" y="3811219"/>
             <a:ext cx="3187690" cy="396118"/>
           </a:xfrm>
           <a:prstGeom prst="rect">
@@ -2433,7 +2433,7 @@
                   <a:schemeClr val="accent3"/>
                 </a:solidFill>
               </a:rPr>
-              <a:t>The app decides by default; people decide only what needs judgement.</a:t>
+              <a:t>The app decides by default; people decide only what needs judgement or a fraud check.</a:t>
             </a:r>
             <a:endParaRPr lang="en-US" sz="1200" dirty="0"/>
           </a:p>
@@ -2447,7 +2447,7 @@
         </p:nvSpPr>
         <p:spPr>
           <a:xfrm>
-            <a:off x="7835859" y="2928823"/>
+            <a:off x="7835859" y="2757465"/>
             <a:ext cx="254020" cy="152430"/>
           </a:xfrm>
           <a:prstGeom prst="rightArrow">
@@ -2467,7 +2467,7 @@
         </p:nvSpPr>
         <p:spPr>
           <a:xfrm>
-            <a:off x="7835859" y="3529767"/>
+            <a:off x="7835859" y="3411718"/>
             <a:ext cx="254020" cy="152430"/>
           </a:xfrm>
           <a:prstGeom prst="rightArrow">
@@ -2487,7 +2487,7 @@
         </p:nvSpPr>
         <p:spPr>
           <a:xfrm>
-            <a:off x="7835859" y="4130802"/>
+            <a:off x="7835859" y="4066062"/>
             <a:ext cx="254020" cy="152430"/>
           </a:xfrm>
           <a:prstGeom prst="rightArrow">
@@ -2507,7 +2507,7 @@
         </p:nvSpPr>
         <p:spPr>
           <a:xfrm>
-            <a:off x="8153430" y="2450592"/>
+            <a:off x="8153430" y="2252533"/>
             <a:ext cx="3670310" cy="182880"/>
           </a:xfrm>
           <a:prstGeom prst="rect">
@@ -2546,12 +2546,12 @@
         </p:nvSpPr>
         <p:spPr>
           <a:xfrm>
-            <a:off x="8153430" y="2696931"/>
-            <a:ext cx="3632180" cy="561167"/>
+            <a:off x="8153430" y="2498964"/>
+            <a:ext cx="3632180" cy="548457"/>
           </a:xfrm>
           <a:prstGeom prst="roundRect">
             <a:avLst>
-              <a:gd name="adj" fmla="val 13579"/>
+              <a:gd name="adj" fmla="val 13894"/>
             </a:avLst>
           </a:prstGeom>
           <a:solidFill>
@@ -2568,12 +2568,12 @@
         </p:nvSpPr>
         <p:spPr>
           <a:xfrm>
-            <a:off x="8191470" y="2696931"/>
-            <a:ext cx="3594141" cy="561167"/>
+            <a:off x="8191470" y="2498964"/>
+            <a:ext cx="3594141" cy="548457"/>
           </a:xfrm>
           <a:prstGeom prst="roundRect">
             <a:avLst>
-              <a:gd name="adj" fmla="val 13579"/>
+              <a:gd name="adj" fmla="val 13894"/>
             </a:avLst>
           </a:prstGeom>
           <a:solidFill>
@@ -2590,7 +2590,7 @@
         </p:nvSpPr>
         <p:spPr>
           <a:xfrm>
-            <a:off x="8318480" y="2779502"/>
+            <a:off x="8318480" y="2575133"/>
             <a:ext cx="3378159" cy="396118"/>
           </a:xfrm>
           <a:prstGeom prst="rect">
@@ -2629,7 +2629,7 @@
                   <a:schemeClr val="tx1"/>
                 </a:solidFill>
               </a:rPr>
-              <a:t> GPDOs delegate parts to attribute owners, who set the rules in the app.</a:t>
+              <a:t> GPDOs delegate parts to attribute owners, who set the app’s settings and decide what it can’t.</a:t>
             </a:r>
             <a:endParaRPr lang="en-US" sz="1200" dirty="0"/>
           </a:p>
@@ -2643,12 +2643,12 @@
         </p:nvSpPr>
         <p:spPr>
           <a:xfrm>
-            <a:off x="8153430" y="3321649"/>
-            <a:ext cx="3632180" cy="561167"/>
+            <a:off x="8153430" y="3110880"/>
+            <a:ext cx="3632180" cy="746516"/>
           </a:xfrm>
           <a:prstGeom prst="roundRect">
             <a:avLst>
-              <a:gd name="adj" fmla="val 13579"/>
+              <a:gd name="adj" fmla="val 10207"/>
             </a:avLst>
           </a:prstGeom>
           <a:solidFill>
@@ -2665,12 +2665,12 @@
         </p:nvSpPr>
         <p:spPr>
           <a:xfrm>
-            <a:off x="8191470" y="3321649"/>
-            <a:ext cx="3594141" cy="561167"/>
+            <a:off x="8191470" y="3110880"/>
+            <a:ext cx="3594141" cy="746516"/>
           </a:xfrm>
           <a:prstGeom prst="roundRect">
             <a:avLst>
-              <a:gd name="adj" fmla="val 13579"/>
+              <a:gd name="adj" fmla="val 10207"/>
             </a:avLst>
           </a:prstGeom>
           <a:solidFill>
@@ -2681,14 +2681,14 @@
       </p:sp>
       <p:sp>
         <p:nvSpPr>
-          <p:cNvPr id="37" name="Text: 2. Enforce. The app checks and approves;"/>
+          <p:cNvPr id="37" name="Text: 2. Enforce. The app checks every request"/>
           <p:cNvSpPr txBox="1"/>
           <p:nvPr/>
         </p:nvSpPr>
         <p:spPr>
           <a:xfrm>
-            <a:off x="8318480" y="3404220"/>
-            <a:ext cx="3378159" cy="396118"/>
+            <a:off x="8318480" y="3187141"/>
+            <a:ext cx="3378159" cy="594086"/>
           </a:xfrm>
           <a:prstGeom prst="rect">
             <a:avLst/>
@@ -2726,7 +2726,7 @@
                   <a:schemeClr val="tx1"/>
                 </a:solidFill>
               </a:rPr>
-              <a:t> The app checks and approves; AI agents prepare, chase and flag.</a:t>
+              <a:t> The app checks every request and approves what owners allow; agents prepare the rest.</a:t>
             </a:r>
             <a:endParaRPr lang="en-US" sz="1200" dirty="0"/>
           </a:p>
@@ -2740,12 +2740,12 @@
         </p:nvSpPr>
         <p:spPr>
           <a:xfrm>
-            <a:off x="8153430" y="3946368"/>
-            <a:ext cx="3632180" cy="561167"/>
+            <a:off x="8153430" y="3920947"/>
+            <a:ext cx="3632180" cy="548457"/>
           </a:xfrm>
           <a:prstGeom prst="roundRect">
             <a:avLst>
-              <a:gd name="adj" fmla="val 13579"/>
+              <a:gd name="adj" fmla="val 13894"/>
             </a:avLst>
           </a:prstGeom>
           <a:solidFill>
@@ -2762,12 +2762,12 @@
         </p:nvSpPr>
         <p:spPr>
           <a:xfrm>
-            <a:off x="8191470" y="3946368"/>
-            <a:ext cx="3594141" cy="561167"/>
+            <a:off x="8191470" y="3920947"/>
+            <a:ext cx="3594141" cy="548457"/>
           </a:xfrm>
           <a:prstGeom prst="roundRect">
             <a:avLst>
-              <a:gd name="adj" fmla="val 13579"/>
+              <a:gd name="adj" fmla="val 13894"/>
             </a:avLst>
           </a:prstGeom>
           <a:solidFill>
@@ -2784,7 +2784,7 @@
         </p:nvSpPr>
         <p:spPr>
           <a:xfrm>
-            <a:off x="8318480" y="4028846"/>
+            <a:off x="8318480" y="3997117"/>
             <a:ext cx="3378159" cy="396118"/>
           </a:xfrm>
           <a:prstGeom prst="rect">
@@ -2823,7 +2823,7 @@
                   <a:schemeClr val="tx1"/>
                 </a:solidFill>
               </a:rPr>
-              <a:t> The data team runs it; internal controls checks the data team.</a:t>
+              <a:t> The data team runs it; internal controls reviews changes made without a request.</a:t>
             </a:r>
             <a:endParaRPr lang="en-US" sz="1200" dirty="0"/>
           </a:p>
@@ -2837,12 +2837,12 @@
         </p:nvSpPr>
         <p:spPr>
           <a:xfrm>
-            <a:off x="406359" y="4621835"/>
-            <a:ext cx="3699845" cy="1688622"/>
+            <a:off x="406359" y="4583704"/>
+            <a:ext cx="3699845" cy="1848551"/>
           </a:xfrm>
           <a:prstGeom prst="roundRect">
             <a:avLst>
-              <a:gd name="adj" fmla="val 6017"/>
+              <a:gd name="adj" fmla="val 5496"/>
             </a:avLst>
           </a:prstGeom>
           <a:solidFill>
@@ -2864,7 +2864,7 @@
         </p:nvSpPr>
         <p:spPr>
           <a:xfrm>
-            <a:off x="577809" y="4742444"/>
+            <a:off x="577809" y="4704314"/>
             <a:ext cx="3395076" cy="182880"/>
           </a:xfrm>
           <a:prstGeom prst="rect">
@@ -2897,13 +2897,13 @@
       </p:sp>
       <p:sp>
         <p:nvSpPr>
-          <p:cNvPr id="43" name="Text: One line each: what must be true 12 fix "/>
+          <p:cNvPr id="43" name="Text: Each says what must be true, and why 12 "/>
           <p:cNvSpPr txBox="1"/>
           <p:nvPr/>
         </p:nvSpPr>
         <p:spPr>
           <a:xfrm>
-            <a:off x="577809" y="4963455"/>
+            <a:off x="577809" y="4925324"/>
             <a:ext cx="3395076" cy="990204"/>
           </a:xfrm>
           <a:prstGeom prst="rect">
@@ -2929,7 +2929,7 @@
                   <a:schemeClr val="tx1"/>
                 </a:solidFill>
               </a:rPr>
-              <a:t>One line each: what must be true</a:t>
+              <a:t>Each says what must be true, and why</a:t>
             </a:r>
             <a:endParaRPr lang="en-US" sz="1200" dirty="0"/>
           </a:p>
@@ -2983,7 +2983,7 @@
                   <a:schemeClr val="tx1"/>
                 </a:solidFill>
               </a:rPr>
-              <a:t>5 apply everywhere from the start</a:t>
+              <a:t>5 of them apply everywhere from the start</a:t>
             </a:r>
             <a:endParaRPr lang="en-US" sz="1200" dirty="0"/>
           </a:p>
@@ -2997,12 +2997,12 @@
         </p:nvSpPr>
         <p:spPr>
           <a:xfrm>
-            <a:off x="4245925" y="4621835"/>
-            <a:ext cx="3699937" cy="1688622"/>
+            <a:off x="4245925" y="4583704"/>
+            <a:ext cx="3699937" cy="1848551"/>
           </a:xfrm>
           <a:prstGeom prst="roundRect">
             <a:avLst>
-              <a:gd name="adj" fmla="val 6017"/>
+              <a:gd name="adj" fmla="val 5496"/>
             </a:avLst>
           </a:prstGeom>
           <a:solidFill>
@@ -3024,7 +3024,7 @@
         </p:nvSpPr>
         <p:spPr>
           <a:xfrm>
-            <a:off x="4417375" y="4742444"/>
+            <a:off x="4417375" y="4704314"/>
             <a:ext cx="3395167" cy="182880"/>
           </a:xfrm>
           <a:prstGeom prst="rect">
@@ -3063,8 +3063,8 @@
         </p:nvSpPr>
         <p:spPr>
           <a:xfrm>
-            <a:off x="4417375" y="4963455"/>
-            <a:ext cx="3395167" cy="990204"/>
+            <a:off x="4417375" y="4925324"/>
+            <a:ext cx="3395167" cy="1386322"/>
           </a:xfrm>
           <a:prstGeom prst="rect">
             <a:avLst/>
@@ -3107,7 +3107,7 @@
                   <a:schemeClr val="tx1"/>
                 </a:solidFill>
               </a:rPr>
-              <a:t>Payment data kept apart from paying</a:t>
+              <a:t>Nobody approves their own request or exception</a:t>
             </a:r>
             <a:endParaRPr lang="en-US" sz="1200" dirty="0"/>
           </a:p>
@@ -3125,7 +3125,7 @@
                   <a:schemeClr val="tx1"/>
                 </a:solidFill>
               </a:rPr>
-              <a:t>Agents never approve, confirm or delete</a:t>
+              <a:t>Payment data kept apart from paying</a:t>
             </a:r>
             <a:endParaRPr lang="en-US" sz="1200" dirty="0"/>
           </a:p>
@@ -3143,7 +3143,7 @@
                   <a:schemeClr val="tx1"/>
                 </a:solidFill>
               </a:rPr>
-              <a:t>Trade secrets stay in controlled AI</a:t>
+              <a:t>Bank details verified with the supplier</a:t>
             </a:r>
             <a:endParaRPr lang="en-US" sz="1200" dirty="0"/>
           </a:p>
@@ -3161,7 +3161,43 @@
                   <a:schemeClr val="tx1"/>
                 </a:solidFill>
               </a:rPr>
-              <a:t>Every change traces to a request</a:t>
+              <a:t>Agents never approve, confirm or delete</a:t>
+            </a:r>
+            <a:endParaRPr lang="en-US" sz="1200" dirty="0"/>
+          </a:p>
+          <a:p>
+            <a:pPr algn="l" marL="165100" indent="-165100">
+              <a:lnSpc>
+                <a:spcPts val="1560"/>
+              </a:lnSpc>
+              <a:buSzPct val="100000"/>
+              <a:buChar char="•"/>
+            </a:pPr>
+            <a:r>
+              <a:rPr lang="en-US" sz="1200" dirty="0">
+                <a:solidFill>
+                  <a:schemeClr val="tx1"/>
+                </a:solidFill>
+              </a:rPr>
+              <a:t>Trade secrets stay in AI the organisation controls</a:t>
+            </a:r>
+            <a:endParaRPr lang="en-US" sz="1200" dirty="0"/>
+          </a:p>
+          <a:p>
+            <a:pPr algn="l" marL="165100" indent="-165100">
+              <a:lnSpc>
+                <a:spcPts val="1560"/>
+              </a:lnSpc>
+              <a:buSzPct val="100000"/>
+              <a:buChar char="•"/>
+            </a:pPr>
+            <a:r>
+              <a:rPr lang="en-US" sz="1200" dirty="0">
+                <a:solidFill>
+                  <a:schemeClr val="tx1"/>
+                </a:solidFill>
+              </a:rPr>
+              <a:t>Every change traces to an approved request</a:t>
             </a:r>
             <a:endParaRPr lang="en-US" sz="1200" dirty="0"/>
           </a:p>
@@ -3175,12 +3211,12 @@
         </p:nvSpPr>
         <p:spPr>
           <a:xfrm>
-            <a:off x="8085673" y="4621835"/>
-            <a:ext cx="3699937" cy="1688622"/>
+            <a:off x="8085673" y="4583704"/>
+            <a:ext cx="3699937" cy="1848551"/>
           </a:xfrm>
           <a:prstGeom prst="roundRect">
             <a:avLst>
-              <a:gd name="adj" fmla="val 6017"/>
+              <a:gd name="adj" fmla="val 5496"/>
             </a:avLst>
           </a:prstGeom>
           <a:solidFill>
@@ -3202,7 +3238,7 @@
         </p:nvSpPr>
         <p:spPr>
           <a:xfrm>
-            <a:off x="8257123" y="4742444"/>
+            <a:off x="8257123" y="4704314"/>
             <a:ext cx="3395167" cy="182880"/>
           </a:xfrm>
           <a:prstGeom prst="rect">
@@ -3241,7 +3277,7 @@
         </p:nvSpPr>
         <p:spPr>
           <a:xfrm>
-            <a:off x="8257123" y="4963455"/>
+            <a:off x="8257123" y="4925324"/>
             <a:ext cx="3395167" cy="990204"/>
           </a:xfrm>
           <a:prstGeom prst="rect">
@@ -3353,7 +3389,7 @@
         </p:nvSpPr>
         <p:spPr>
           <a:xfrm>
-            <a:off x="8257123" y="5991697"/>
+            <a:off x="8257123" y="5953658"/>
             <a:ext cx="3395167" cy="198059"/>
           </a:xfrm>
           <a:prstGeom prst="rect">
@@ -3531,11 +3567,11 @@
         <p:spPr>
           <a:xfrm>
             <a:off x="406359" y="807598"/>
-            <a:ext cx="6881409" cy="1330635"/>
+            <a:ext cx="6881409" cy="1528694"/>
           </a:xfrm>
           <a:prstGeom prst="roundRect">
             <a:avLst>
-              <a:gd name="adj" fmla="val 7635"/>
+              <a:gd name="adj" fmla="val 6646"/>
             </a:avLst>
           </a:prstGeom>
           <a:solidFill>
@@ -3552,7 +3588,7 @@
         </p:nvSpPr>
         <p:spPr>
           <a:xfrm>
-            <a:off x="634959" y="1095817"/>
+            <a:off x="634959" y="1194755"/>
             <a:ext cx="6462339" cy="182880"/>
           </a:xfrm>
           <a:prstGeom prst="rect">
@@ -3591,7 +3627,7 @@
         </p:nvSpPr>
         <p:spPr>
           <a:xfrm>
-            <a:off x="634959" y="1354866"/>
+            <a:off x="634959" y="1453896"/>
             <a:ext cx="6462339" cy="495330"/>
           </a:xfrm>
           <a:prstGeom prst="rect">
@@ -3619,7 +3655,7 @@
                 <a:ea typeface="+mj-lt" pitchFamily="34" charset="-122"/>
                 <a:cs typeface="+mj-lt" pitchFamily="34" charset="-120"/>
               </a:rPr>
-              <a:t>Every piece of data has one named owner. A routine change needs one person, the requester; a sensitive change needs two.</a:t>
+              <a:t>Every piece of data has one named owner. A routine change needs one person, the requester; a sensitive change, such as to bank details, needs two.</a:t>
             </a:r>
             <a:endParaRPr lang="en-US" sz="1500" dirty="0"/>
           </a:p>
@@ -3634,11 +3670,11 @@
         <p:spPr>
           <a:xfrm>
             <a:off x="7427488" y="807598"/>
-            <a:ext cx="4358122" cy="1330635"/>
+            <a:ext cx="4358122" cy="1528694"/>
           </a:xfrm>
           <a:prstGeom prst="roundRect">
             <a:avLst>
-              <a:gd name="adj" fmla="val 7635"/>
+              <a:gd name="adj" fmla="val 6646"/>
             </a:avLst>
           </a:prstGeom>
           <a:solidFill>
@@ -3753,7 +3789,7 @@
         <p:spPr>
           <a:xfrm>
             <a:off x="7598938" y="1385407"/>
-            <a:ext cx="4053261" cy="198059"/>
+            <a:ext cx="4053261" cy="396118"/>
           </a:xfrm>
           <a:prstGeom prst="rect">
             <a:avLst/>
@@ -3791,7 +3827,7 @@
                   <a:schemeClr val="tx1"/>
                 </a:solidFill>
               </a:rPr>
-              <a:t> the platform owner</a:t>
+              <a:t> the platform owner, after the owner review if they add work</a:t>
             </a:r>
             <a:endParaRPr lang="en-US" sz="1200" dirty="0"/>
           </a:p>
@@ -3805,7 +3841,7 @@
         </p:nvSpPr>
         <p:spPr>
           <a:xfrm>
-            <a:off x="7598938" y="1621506"/>
+            <a:off x="7598938" y="1819565"/>
             <a:ext cx="4053261" cy="396118"/>
           </a:xfrm>
           <a:prstGeom prst="rect">
@@ -3858,7 +3894,7 @@
         </p:nvSpPr>
         <p:spPr>
           <a:xfrm>
-            <a:off x="406359" y="2252533"/>
+            <a:off x="406359" y="2450592"/>
             <a:ext cx="3594141" cy="182880"/>
           </a:xfrm>
           <a:prstGeom prst="rect">
@@ -3897,12 +3933,12 @@
         </p:nvSpPr>
         <p:spPr>
           <a:xfrm>
-            <a:off x="406359" y="2498964"/>
-            <a:ext cx="3556010" cy="1640251"/>
+            <a:off x="406359" y="2696931"/>
+            <a:ext cx="3556010" cy="1838310"/>
           </a:xfrm>
           <a:prstGeom prst="roundRect">
             <a:avLst>
-              <a:gd name="adj" fmla="val 4646"/>
+              <a:gd name="adj" fmla="val 4145"/>
             </a:avLst>
           </a:prstGeom>
           <a:solidFill>
@@ -3924,7 +3960,7 @@
         </p:nvSpPr>
         <p:spPr>
           <a:xfrm>
-            <a:off x="539770" y="2606863"/>
+            <a:off x="539770" y="2804922"/>
             <a:ext cx="3327410" cy="1188263"/>
           </a:xfrm>
           <a:prstGeom prst="rect">
@@ -4022,7 +4058,7 @@
                   <a:schemeClr val="tx1"/>
                 </a:solidFill>
               </a:rPr>
-              <a:t>Decides what’s escalated</a:t>
+              <a:t>Decides what’s escalated to them</a:t>
             </a:r>
             <a:endParaRPr lang="en-US" sz="1200" dirty="0"/>
           </a:p>
@@ -4036,7 +4072,7 @@
         </p:nvSpPr>
         <p:spPr>
           <a:xfrm>
-            <a:off x="4025920" y="3243468"/>
+            <a:off x="4025920" y="3540557"/>
             <a:ext cx="254020" cy="152430"/>
           </a:xfrm>
           <a:prstGeom prst="rightArrow">
@@ -4056,7 +4092,7 @@
         </p:nvSpPr>
         <p:spPr>
           <a:xfrm>
-            <a:off x="4343400" y="2252533"/>
+            <a:off x="4343400" y="2450592"/>
             <a:ext cx="3594141" cy="182880"/>
           </a:xfrm>
           <a:prstGeom prst="rect">
@@ -4095,12 +4131,12 @@
         </p:nvSpPr>
         <p:spPr>
           <a:xfrm>
-            <a:off x="4343400" y="2498964"/>
-            <a:ext cx="3556010" cy="1640251"/>
+            <a:off x="4343400" y="2696931"/>
+            <a:ext cx="3556010" cy="1838310"/>
           </a:xfrm>
           <a:prstGeom prst="roundRect">
             <a:avLst>
-              <a:gd name="adj" fmla="val 4646"/>
+              <a:gd name="adj" fmla="val 4145"/>
             </a:avLst>
           </a:prstGeom>
           <a:solidFill>
@@ -4122,8 +4158,8 @@
         </p:nvSpPr>
         <p:spPr>
           <a:xfrm>
-            <a:off x="4476720" y="2606863"/>
-            <a:ext cx="3327410" cy="1188263"/>
+            <a:off x="4476720" y="2804922"/>
+            <a:ext cx="3327410" cy="1386322"/>
           </a:xfrm>
           <a:prstGeom prst="rect">
             <a:avLst/>
@@ -4166,7 +4202,7 @@
                   <a:schemeClr val="tx1"/>
                 </a:solidFill>
               </a:rPr>
-              <a:t>Sets its rules as settings in the app</a:t>
+              <a:t>Sets its checks, sensitive fields and other settings in the app</a:t>
             </a:r>
             <a:endParaRPr lang="en-US" sz="1200" dirty="0"/>
           </a:p>
@@ -4234,7 +4270,7 @@
         </p:nvSpPr>
         <p:spPr>
           <a:xfrm>
-            <a:off x="7962870" y="3243468"/>
+            <a:off x="7962870" y="3540557"/>
             <a:ext cx="254020" cy="152430"/>
           </a:xfrm>
           <a:prstGeom prst="rightArrow">
@@ -4254,7 +4290,7 @@
         </p:nvSpPr>
         <p:spPr>
           <a:xfrm>
-            <a:off x="8280441" y="2252533"/>
+            <a:off x="8280441" y="2450592"/>
             <a:ext cx="3543300" cy="182880"/>
           </a:xfrm>
           <a:prstGeom prst="rect">
@@ -4293,12 +4329,12 @@
         </p:nvSpPr>
         <p:spPr>
           <a:xfrm>
-            <a:off x="8280441" y="2498964"/>
-            <a:ext cx="3505170" cy="1640251"/>
+            <a:off x="8280441" y="2696931"/>
+            <a:ext cx="3505170" cy="1838310"/>
           </a:xfrm>
           <a:prstGeom prst="roundRect">
             <a:avLst>
-              <a:gd name="adj" fmla="val 4646"/>
+              <a:gd name="adj" fmla="val 4145"/>
             </a:avLst>
           </a:prstGeom>
           <a:solidFill>
@@ -4315,12 +4351,12 @@
         </p:nvSpPr>
         <p:spPr>
           <a:xfrm>
-            <a:off x="8318480" y="2498964"/>
-            <a:ext cx="3467130" cy="1640251"/>
+            <a:off x="8318480" y="2696931"/>
+            <a:ext cx="3467130" cy="1838310"/>
           </a:xfrm>
           <a:prstGeom prst="roundRect">
             <a:avLst>
-              <a:gd name="adj" fmla="val 4646"/>
+              <a:gd name="adj" fmla="val 4145"/>
             </a:avLst>
           </a:prstGeom>
           <a:solidFill>
@@ -4331,13 +4367,13 @@
       </p:sp>
       <p:sp>
         <p:nvSpPr>
-          <p:cNvPr id="24" name="Text: At least two per part, from any team Con"/>
+          <p:cNvPr id="24" name="Text: Optional: two or more, shared across par"/>
           <p:cNvSpPr txBox="1"/>
           <p:nvPr/>
         </p:nvSpPr>
         <p:spPr>
           <a:xfrm>
-            <a:off x="8445490" y="2600554"/>
+            <a:off x="8445490" y="2798521"/>
             <a:ext cx="3251241" cy="990204"/>
           </a:xfrm>
           <a:prstGeom prst="rect">
@@ -4363,7 +4399,7 @@
                   <a:schemeClr val="tx1"/>
                 </a:solidFill>
               </a:rPr>
-              <a:t>At least two per part, from any team</a:t>
+              <a:t>Optional: two or more, shared across parts</a:t>
             </a:r>
             <a:endParaRPr lang="en-US" sz="1200" dirty="0"/>
           </a:p>
@@ -4431,8 +4467,8 @@
         </p:nvSpPr>
         <p:spPr>
           <a:xfrm>
-            <a:off x="8445490" y="3641507"/>
-            <a:ext cx="3251241" cy="396118"/>
+            <a:off x="8445490" y="3839566"/>
+            <a:ext cx="3251241" cy="594086"/>
           </a:xfrm>
           <a:prstGeom prst="rect">
             <a:avLst/>
@@ -4456,7 +4492,7 @@
                   <a:schemeClr val="accent5"/>
                 </a:solidFill>
               </a:rPr>
-              <a:t>Never settings, exceptions, mass changes or access. Whoever confirms payment data can’t buy or pay.</a:t>
+              <a:t>Never settings, exceptions, mass changes or access. Payment confirmers can’t buy, pay or release credit.</a:t>
             </a:r>
             <a:endParaRPr lang="en-US" sz="1200" dirty="0"/>
           </a:p>
@@ -4470,7 +4506,7 @@
         </p:nvSpPr>
         <p:spPr>
           <a:xfrm>
-            <a:off x="406359" y="4253514"/>
+            <a:off x="406359" y="4649633"/>
             <a:ext cx="3699845" cy="1688622"/>
           </a:xfrm>
           <a:prstGeom prst="roundRect">
@@ -4497,7 +4533,7 @@
         </p:nvSpPr>
         <p:spPr>
           <a:xfrm>
-            <a:off x="577809" y="4374124"/>
+            <a:off x="577809" y="4770242"/>
             <a:ext cx="3395076" cy="182880"/>
           </a:xfrm>
           <a:prstGeom prst="rect">
@@ -4536,7 +4572,7 @@
         </p:nvSpPr>
         <p:spPr>
           <a:xfrm>
-            <a:off x="577809" y="4595134"/>
+            <a:off x="577809" y="4991161"/>
             <a:ext cx="3395076" cy="198059"/>
           </a:xfrm>
           <a:prstGeom prst="rect">
@@ -4589,7 +4625,7 @@
         </p:nvSpPr>
         <p:spPr>
           <a:xfrm>
-            <a:off x="577809" y="4831232"/>
+            <a:off x="577809" y="5227350"/>
             <a:ext cx="3395076" cy="990204"/>
           </a:xfrm>
           <a:prstGeom prst="rect">
@@ -4665,7 +4701,7 @@
         </p:nvSpPr>
         <p:spPr>
           <a:xfrm>
-            <a:off x="4245925" y="4253514"/>
+            <a:off x="4245925" y="4649633"/>
             <a:ext cx="3699937" cy="1688622"/>
           </a:xfrm>
           <a:prstGeom prst="roundRect">
@@ -4692,7 +4728,7 @@
         </p:nvSpPr>
         <p:spPr>
           <a:xfrm>
-            <a:off x="4417375" y="4374124"/>
+            <a:off x="4417375" y="4770242"/>
             <a:ext cx="3395167" cy="182880"/>
           </a:xfrm>
           <a:prstGeom prst="rect">
@@ -4731,7 +4767,7 @@
         </p:nvSpPr>
         <p:spPr>
           <a:xfrm>
-            <a:off x="4417375" y="4595134"/>
+            <a:off x="4417375" y="4991161"/>
             <a:ext cx="3395167" cy="198059"/>
           </a:xfrm>
           <a:prstGeom prst="rect">
@@ -4770,7 +4806,7 @@
         </p:nvSpPr>
         <p:spPr>
           <a:xfrm>
-            <a:off x="4417375" y="4831232"/>
+            <a:off x="4417375" y="5227350"/>
             <a:ext cx="3395167" cy="990204"/>
           </a:xfrm>
           <a:prstGeom prst="rect">
@@ -4864,7 +4900,7 @@
         </p:nvSpPr>
         <p:spPr>
           <a:xfrm>
-            <a:off x="8085673" y="4253514"/>
+            <a:off x="8085673" y="4649633"/>
             <a:ext cx="3699937" cy="1688622"/>
           </a:xfrm>
           <a:prstGeom prst="roundRect">
@@ -4891,7 +4927,7 @@
         </p:nvSpPr>
         <p:spPr>
           <a:xfrm>
-            <a:off x="8257123" y="4374124"/>
+            <a:off x="8257123" y="4770242"/>
             <a:ext cx="3395167" cy="182880"/>
           </a:xfrm>
           <a:prstGeom prst="rect">
@@ -4930,7 +4966,7 @@
         </p:nvSpPr>
         <p:spPr>
           <a:xfrm>
-            <a:off x="8257123" y="4595134"/>
+            <a:off x="8257123" y="4991161"/>
             <a:ext cx="3395167" cy="198059"/>
           </a:xfrm>
           <a:prstGeom prst="rect">
@@ -4983,7 +5019,7 @@
         </p:nvSpPr>
         <p:spPr>
           <a:xfrm>
-            <a:off x="8257123" y="4831232"/>
+            <a:off x="8257123" y="5227350"/>
             <a:ext cx="3395167" cy="594086"/>
           </a:xfrm>
           <a:prstGeom prst="rect">
@@ -5045,7 +5081,7 @@
                   <a:schemeClr val="tx1"/>
                 </a:solidFill>
               </a:rPr>
-              <a:t>Samples the change reconciler’s matches</a:t>
+              <a:t>Samples the change reconciler agent’s matches</a:t>
             </a:r>
             <a:endParaRPr lang="en-US" sz="1200" dirty="0"/>
           </a:p>
@@ -5238,7 +5274,7 @@
       </p:sp>
       <p:sp>
         <p:nvSpPr>
-          <p:cNvPr id="7" name="Text: 22 one-line rules in seven groups say wh"/>
+          <p:cNvPr id="7" name="Text: 22 short rules in seven groups say what "/>
           <p:cNvSpPr txBox="1"/>
           <p:nvPr/>
         </p:nvSpPr>
@@ -5272,7 +5308,7 @@
                 <a:ea typeface="+mj-lt" pitchFamily="34" charset="-122"/>
                 <a:cs typeface="+mj-lt" pitchFamily="34" charset="-120"/>
               </a:rPr>
-              <a:t>22 one-line rules in seven groups say what must be true; the controls say how. Each domain sets what good data looks like in its profile.</a:t>
+              <a:t>22 short rules in seven groups say what must be true; the controls say how. Each domain sets what good data looks like in its profile.</a:t>
             </a:r>
             <a:endParaRPr lang="en-US" sz="1500" dirty="0"/>
           </a:p>
@@ -5672,7 +5708,7 @@
                   <a:schemeClr val="tx1"/>
                 </a:solidFill>
               </a:rPr>
-              <a:t>Every domain has a named owner, its GPDO, and every field exactly one owner.</a:t>
+              <a:t>Every domain has a named owner, its GPDO, and every field on every record exactly one owner.</a:t>
             </a:r>
             <a:endParaRPr lang="en-US" sz="1200" dirty="0"/>
           </a:p>
@@ -5785,14 +5821,14 @@
       </p:sp>
       <p:sp>
         <p:nvSpPr>
-          <p:cNvPr id="19" name="Text: One governed way in, and one system of r"/>
+          <p:cNvPr id="19" name="Text: Changes only through the governed proces"/>
           <p:cNvSpPr txBox="1"/>
           <p:nvPr/>
         </p:nvSpPr>
         <p:spPr>
           <a:xfrm>
-            <a:off x="2444740" y="4025920"/>
-            <a:ext cx="3486150" cy="792145"/>
+            <a:off x="2444740" y="3926891"/>
+            <a:ext cx="3486150" cy="990204"/>
           </a:xfrm>
           <a:prstGeom prst="rect">
             <a:avLst/>
@@ -5816,7 +5852,7 @@
                   <a:schemeClr val="tx1"/>
                 </a:solidFill>
               </a:rPr>
-              <a:t>One governed way in, and one system of record for each field. Requests are checked, then approved by the app or the owner; mass changes need sign-off; every change traces to a request.</a:t>
+              <a:t>Changes only through the governed process, with one system of record for each field. Requests are checked, then approved by the app as owners allow, or by an owner; mass changes need sign-off; every change traces to an approved request.</a:t>
             </a:r>
             <a:endParaRPr lang="en-US" sz="1200" dirty="0"/>
           </a:p>
@@ -6014,11 +6050,11 @@
         <p:spPr>
           <a:xfrm>
             <a:off x="6165891" y="2316358"/>
-            <a:ext cx="5619720" cy="995690"/>
+            <a:ext cx="5619720" cy="1008035"/>
           </a:xfrm>
           <a:prstGeom prst="roundRect">
             <a:avLst>
-              <a:gd name="adj" fmla="val 7653"/>
+              <a:gd name="adj" fmla="val 7559"/>
             </a:avLst>
           </a:prstGeom>
           <a:solidFill>
@@ -6040,7 +6076,7 @@
         </p:nvSpPr>
         <p:spPr>
           <a:xfrm>
-            <a:off x="6299210" y="2609789"/>
+            <a:off x="6299210" y="2616007"/>
             <a:ext cx="1816090" cy="198059"/>
           </a:xfrm>
           <a:prstGeom prst="rect">
@@ -6079,7 +6115,7 @@
         </p:nvSpPr>
         <p:spPr>
           <a:xfrm>
-            <a:off x="6299210" y="2820467"/>
+            <a:off x="6299210" y="2826776"/>
             <a:ext cx="1816090" cy="198059"/>
           </a:xfrm>
           <a:prstGeom prst="rect">
@@ -6112,14 +6148,14 @@
       </p:sp>
       <p:sp>
         <p:nvSpPr>
-          <p:cNvPr id="28" name="Text: Someone else confirms sensitive changes,"/>
+          <p:cNvPr id="28" name="Text: Changes to sensitive fields, such as ban"/>
           <p:cNvSpPr txBox="1"/>
           <p:nvPr/>
         </p:nvSpPr>
         <p:spPr>
           <a:xfrm>
-            <a:off x="8204180" y="2517069"/>
-            <a:ext cx="3486150" cy="594086"/>
+            <a:off x="8204180" y="2424349"/>
+            <a:ext cx="3486150" cy="792145"/>
           </a:xfrm>
           <a:prstGeom prst="rect">
             <a:avLst/>
@@ -6143,7 +6179,7 @@
                   <a:schemeClr val="tx1"/>
                 </a:solidFill>
               </a:rPr>
-              <a:t>Someone else confirms sensitive changes, payment data is kept apart from paying, and bank changes are verified with the supplier.</a:t>
+              <a:t>Changes to sensitive fields, such as bank details, need someone else to confirm them. Payment data is kept apart from paying, and bank changes are verified with the supplier.</a:t>
             </a:r>
             <a:endParaRPr lang="en-US" sz="1200" dirty="0"/>
           </a:p>
@@ -6157,12 +6193,12 @@
         </p:nvSpPr>
         <p:spPr>
           <a:xfrm>
-            <a:off x="6165891" y="3388218"/>
-            <a:ext cx="5619720" cy="995782"/>
+            <a:off x="6165891" y="3400654"/>
+            <a:ext cx="5619720" cy="1008035"/>
           </a:xfrm>
           <a:prstGeom prst="roundRect">
             <a:avLst>
-              <a:gd name="adj" fmla="val 7652"/>
+              <a:gd name="adj" fmla="val 7559"/>
             </a:avLst>
           </a:prstGeom>
           <a:solidFill>
@@ -6184,7 +6220,7 @@
         </p:nvSpPr>
         <p:spPr>
           <a:xfrm>
-            <a:off x="6299210" y="3582711"/>
+            <a:off x="6299210" y="3601273"/>
             <a:ext cx="1816090" cy="396118"/>
           </a:xfrm>
           <a:prstGeom prst="rect">
@@ -6223,7 +6259,7 @@
         </p:nvSpPr>
         <p:spPr>
           <a:xfrm>
-            <a:off x="6299210" y="3991447"/>
+            <a:off x="6299210" y="4010010"/>
             <a:ext cx="1816090" cy="198059"/>
           </a:xfrm>
           <a:prstGeom prst="rect">
@@ -6262,8 +6298,8 @@
         </p:nvSpPr>
         <p:spPr>
           <a:xfrm>
-            <a:off x="8204180" y="3589020"/>
-            <a:ext cx="3486150" cy="594086"/>
+            <a:off x="8204180" y="3508553"/>
+            <a:ext cx="3486150" cy="792145"/>
           </a:xfrm>
           <a:prstGeom prst="rect">
             <a:avLst/>
@@ -6287,7 +6323,7 @@
                   <a:schemeClr val="tx1"/>
                 </a:solidFill>
               </a:rPr>
-              <a:t>Classified fields, with access only where needed. Trade secrets are Restricted everywhere; personal data is blocked, then deleted.</a:t>
+              <a:t>Classified fields, with access only where needed. Trade secrets get the highest classification everywhere. Personal data is blocked when its purpose ends, then deleted.</a:t>
             </a:r>
             <a:endParaRPr lang="en-US" sz="1200" dirty="0"/>
           </a:p>
@@ -6301,12 +6337,12 @@
         </p:nvSpPr>
         <p:spPr>
           <a:xfrm>
-            <a:off x="6165891" y="4460169"/>
-            <a:ext cx="5619720" cy="995690"/>
+            <a:off x="6165891" y="4484858"/>
+            <a:ext cx="5619720" cy="983346"/>
           </a:xfrm>
           <a:prstGeom prst="roundRect">
             <a:avLst>
-              <a:gd name="adj" fmla="val 7653"/>
+              <a:gd name="adj" fmla="val 7749"/>
             </a:avLst>
           </a:prstGeom>
           <a:solidFill>
@@ -6328,7 +6364,7 @@
         </p:nvSpPr>
         <p:spPr>
           <a:xfrm>
-            <a:off x="6299210" y="4753600"/>
+            <a:off x="6299210" y="4772162"/>
             <a:ext cx="1816090" cy="198059"/>
           </a:xfrm>
           <a:prstGeom prst="rect">
@@ -6367,7 +6403,7 @@
         </p:nvSpPr>
         <p:spPr>
           <a:xfrm>
-            <a:off x="6299210" y="4964278"/>
+            <a:off x="6299210" y="4982840"/>
             <a:ext cx="1816090" cy="198059"/>
           </a:xfrm>
           <a:prstGeom prst="rect">
@@ -6406,7 +6442,7 @@
         </p:nvSpPr>
         <p:spPr>
           <a:xfrm>
-            <a:off x="8204180" y="4660880"/>
+            <a:off x="8204180" y="4679442"/>
             <a:ext cx="3486150" cy="594086"/>
           </a:xfrm>
           <a:prstGeom prst="rect">
@@ -6431,7 +6467,7 @@
                   <a:schemeClr val="tx1"/>
                 </a:solidFill>
               </a:rPr>
-              <a:t>Agents are registered, limited and logged. AI treats outside content as data, and outside models need approval.</a:t>
+              <a:t>Agents are registered, limited and logged. AI never takes instructions from outside content; outside models need approval and never get trade secrets.</a:t>
             </a:r>
             <a:endParaRPr lang="en-US" sz="1200" dirty="0"/>
           </a:p>
@@ -6445,12 +6481,12 @@
         </p:nvSpPr>
         <p:spPr>
           <a:xfrm>
-            <a:off x="6165891" y="5532029"/>
-            <a:ext cx="5619720" cy="995782"/>
+            <a:off x="6165891" y="5544464"/>
+            <a:ext cx="5619720" cy="983346"/>
           </a:xfrm>
           <a:prstGeom prst="roundRect">
             <a:avLst>
-              <a:gd name="adj" fmla="val 7652"/>
+              <a:gd name="adj" fmla="val 7749"/>
             </a:avLst>
           </a:prstGeom>
           <a:solidFill>
@@ -6472,7 +6508,7 @@
         </p:nvSpPr>
         <p:spPr>
           <a:xfrm>
-            <a:off x="6299210" y="5825551"/>
+            <a:off x="6299210" y="5831677"/>
             <a:ext cx="1816090" cy="198059"/>
           </a:xfrm>
           <a:prstGeom prst="rect">
@@ -6511,7 +6547,7 @@
         </p:nvSpPr>
         <p:spPr>
           <a:xfrm>
-            <a:off x="6299210" y="6036229"/>
+            <a:off x="6299210" y="6042447"/>
             <a:ext cx="1816090" cy="198059"/>
           </a:xfrm>
           <a:prstGeom prst="rect">
@@ -6550,7 +6586,7 @@
         </p:nvSpPr>
         <p:spPr>
           <a:xfrm>
-            <a:off x="8204180" y="5732831"/>
+            <a:off x="8204180" y="5739049"/>
             <a:ext cx="3486150" cy="594086"/>
           </a:xfrm>
           <a:prstGeom prst="rect">
@@ -6768,7 +6804,7 @@
       </p:sp>
       <p:sp>
         <p:nvSpPr>
-          <p:cNvPr id="7" name="Text: GPDOs set up the domain, attribute owner"/>
+          <p:cNvPr id="7" name="Text: GPDOs set up the domain. Attribute owner"/>
           <p:cNvSpPr txBox="1"/>
           <p:nvPr/>
         </p:nvSpPr>
@@ -6802,7 +6838,7 @@
                 <a:ea typeface="+mj-lt" pitchFamily="34" charset="-122"/>
                 <a:cs typeface="+mj-lt" pitchFamily="34" charset="-120"/>
               </a:rPr>
-              <a:t>GPDOs set up the domain, attribute owners set their parts, and delegates decide the daily cases. The data team runs the platform.</a:t>
+              <a:t>GPDOs set up the domain. Attribute owners set their parts and decide the daily cases, or hand them to delegates. The data team runs the platform.</a:t>
             </a:r>
             <a:endParaRPr lang="en-US" sz="1500" dirty="0"/>
           </a:p>
@@ -6992,8 +7028,8 @@
               <a:tblPr/>
               <a:tblGrid>
                 <a:gridCol w="2047067"/>
-                <a:gridCol w="3866815"/>
-                <a:gridCol w="909737"/>
+                <a:gridCol w="3980566"/>
+                <a:gridCol w="796077"/>
                 <a:gridCol w="1250991"/>
                 <a:gridCol w="909737"/>
                 <a:gridCol w="1250991"/>
@@ -7872,7 +7908,7 @@
                             <a:schemeClr val="tx2"/>
                           </a:solidFill>
                         </a:rPr>
-                        <a:t>Set each part’s rules</a:t>
+                        <a:t>Set each part’s settings</a:t>
                       </a:r>
                       <a:endParaRPr lang="en-US" sz="1200" dirty="0"/>
                     </a:p>
@@ -7933,7 +7969,7 @@
                             <a:schemeClr val="accent5"/>
                           </a:solidFill>
                         </a:rPr>
-                        <a:t>Settings and access; exceptions and mass changes</a:t>
+                        <a:t>Checks, automatic approvals, exceptions, mass changes</a:t>
                       </a:r>
                       <a:endParaRPr lang="en-US" sz="1200" dirty="0"/>
                     </a:p>
@@ -8239,6 +8275,435 @@
                           </a:solidFill>
                         </a:rPr>
                         <a:t>As needed</a:t>
+                      </a:r>
+                      <a:endParaRPr lang="en-US" sz="1200" dirty="0"/>
+                    </a:p>
+                  </a:txBody>
+                  <a:tcPr marL="91440" marR="91440" marT="53340" marB="53340" anchor="ctr">
+                    <a:lnL w="6350" cap="flat" cmpd="sng" algn="ctr">
+                      <a:solidFill>
+                        <a:schemeClr val="accent6"/>
+                      </a:solidFill>
+                      <a:prstDash val="solid"/>
+                      <a:round/>
+                      <a:headEnd type="none" w="med" len="med"/>
+                      <a:tailEnd type="none" w="med" len="med"/>
+                    </a:lnL>
+                    <a:lnR w="6350" cap="flat" cmpd="sng" algn="ctr">
+                      <a:solidFill>
+                        <a:schemeClr val="accent6"/>
+                      </a:solidFill>
+                      <a:prstDash val="solid"/>
+                      <a:round/>
+                      <a:headEnd type="none" w="med" len="med"/>
+                      <a:tailEnd type="none" w="med" len="med"/>
+                    </a:lnR>
+                    <a:lnT w="6350" cap="flat" cmpd="sng" algn="ctr">
+                      <a:solidFill>
+                        <a:schemeClr val="accent6"/>
+                      </a:solidFill>
+                      <a:prstDash val="solid"/>
+                      <a:round/>
+                      <a:headEnd type="none" w="med" len="med"/>
+                      <a:tailEnd type="none" w="med" len="med"/>
+                    </a:lnT>
+                    <a:lnB w="6350" cap="flat" cmpd="sng" algn="ctr">
+                      <a:solidFill>
+                        <a:schemeClr val="accent6"/>
+                      </a:solidFill>
+                      <a:prstDash val="solid"/>
+                      <a:round/>
+                      <a:headEnd type="none" w="med" len="med"/>
+                      <a:tailEnd type="none" w="med" len="med"/>
+                    </a:lnB>
+                    <a:solidFill>
+                      <a:schemeClr val="bg1"/>
+                    </a:solidFill>
+                  </a:tcPr>
+                </a:tc>
+              </a:tr>
+              <a:tr h="326258">
+                <a:tc>
+                  <a:txBody>
+                    <a:bodyPr/>
+                    <a:lstStyle/>
+                    <a:p>
+                      <a:pPr algn="l" indent="0" marL="0">
+                        <a:buNone/>
+                      </a:pPr>
+                      <a:r>
+                        <a:rPr lang="en-US" sz="1200" dirty="0">
+                          <a:solidFill>
+                            <a:schemeClr val="tx2"/>
+                          </a:solidFill>
+                        </a:rPr>
+                        <a:t>Control access</a:t>
+                      </a:r>
+                      <a:endParaRPr lang="en-US" sz="1200" dirty="0"/>
+                    </a:p>
+                  </a:txBody>
+                  <a:tcPr marL="91440" marR="91440" marT="53340" marB="53340" anchor="ctr">
+                    <a:lnL w="6350" cap="flat" cmpd="sng" algn="ctr">
+                      <a:solidFill>
+                        <a:schemeClr val="accent6"/>
+                      </a:solidFill>
+                      <a:prstDash val="solid"/>
+                      <a:round/>
+                      <a:headEnd type="none" w="med" len="med"/>
+                      <a:tailEnd type="none" w="med" len="med"/>
+                    </a:lnL>
+                    <a:lnR w="6350" cap="flat" cmpd="sng" algn="ctr">
+                      <a:solidFill>
+                        <a:schemeClr val="accent6"/>
+                      </a:solidFill>
+                      <a:prstDash val="solid"/>
+                      <a:round/>
+                      <a:headEnd type="none" w="med" len="med"/>
+                      <a:tailEnd type="none" w="med" len="med"/>
+                    </a:lnR>
+                    <a:lnT w="6350" cap="flat" cmpd="sng" algn="ctr">
+                      <a:solidFill>
+                        <a:schemeClr val="accent6"/>
+                      </a:solidFill>
+                      <a:prstDash val="solid"/>
+                      <a:round/>
+                      <a:headEnd type="none" w="med" len="med"/>
+                      <a:tailEnd type="none" w="med" len="med"/>
+                    </a:lnT>
+                    <a:lnB w="6350" cap="flat" cmpd="sng" algn="ctr">
+                      <a:solidFill>
+                        <a:schemeClr val="accent6"/>
+                      </a:solidFill>
+                      <a:prstDash val="solid"/>
+                      <a:round/>
+                      <a:headEnd type="none" w="med" len="med"/>
+                      <a:tailEnd type="none" w="med" len="med"/>
+                    </a:lnB>
+                    <a:solidFill>
+                      <a:schemeClr val="bg1"/>
+                    </a:solidFill>
+                  </a:tcPr>
+                </a:tc>
+                <a:tc>
+                  <a:txBody>
+                    <a:bodyPr/>
+                    <a:lstStyle/>
+                    <a:p>
+                      <a:pPr algn="l" indent="0" marL="0">
+                        <a:buNone/>
+                      </a:pPr>
+                      <a:r>
+                        <a:rPr lang="en-US" sz="1200" dirty="0">
+                          <a:solidFill>
+                            <a:schemeClr val="accent5"/>
+                          </a:solidFill>
+                        </a:rPr>
+                        <a:t>Who sees classified data; access reviews; extracts</a:t>
+                      </a:r>
+                      <a:endParaRPr lang="en-US" sz="1200" dirty="0"/>
+                    </a:p>
+                  </a:txBody>
+                  <a:tcPr marL="91440" marR="91440" marT="53340" marB="53340" anchor="ctr">
+                    <a:lnL w="6350" cap="flat" cmpd="sng" algn="ctr">
+                      <a:solidFill>
+                        <a:schemeClr val="accent6"/>
+                      </a:solidFill>
+                      <a:prstDash val="solid"/>
+                      <a:round/>
+                      <a:headEnd type="none" w="med" len="med"/>
+                      <a:tailEnd type="none" w="med" len="med"/>
+                    </a:lnL>
+                    <a:lnR w="6350" cap="flat" cmpd="sng" algn="ctr">
+                      <a:solidFill>
+                        <a:schemeClr val="accent6"/>
+                      </a:solidFill>
+                      <a:prstDash val="solid"/>
+                      <a:round/>
+                      <a:headEnd type="none" w="med" len="med"/>
+                      <a:tailEnd type="none" w="med" len="med"/>
+                    </a:lnR>
+                    <a:lnT w="6350" cap="flat" cmpd="sng" algn="ctr">
+                      <a:solidFill>
+                        <a:schemeClr val="accent6"/>
+                      </a:solidFill>
+                      <a:prstDash val="solid"/>
+                      <a:round/>
+                      <a:headEnd type="none" w="med" len="med"/>
+                      <a:tailEnd type="none" w="med" len="med"/>
+                    </a:lnT>
+                    <a:lnB w="6350" cap="flat" cmpd="sng" algn="ctr">
+                      <a:solidFill>
+                        <a:schemeClr val="accent6"/>
+                      </a:solidFill>
+                      <a:prstDash val="solid"/>
+                      <a:round/>
+                      <a:headEnd type="none" w="med" len="med"/>
+                      <a:tailEnd type="none" w="med" len="med"/>
+                    </a:lnB>
+                    <a:solidFill>
+                      <a:schemeClr val="bg1"/>
+                    </a:solidFill>
+                  </a:tcPr>
+                </a:tc>
+                <a:tc>
+                  <a:txBody>
+                    <a:bodyPr/>
+                    <a:lstStyle/>
+                    <a:p>
+                      <a:pPr algn="ctr" indent="0" marL="0">
+                        <a:buNone/>
+                      </a:pPr>
+                      <a:r>
+                        <a:rPr lang="en-US" sz="1200" dirty="0">
+                          <a:solidFill>
+                            <a:schemeClr val="accent5"/>
+                          </a:solidFill>
+                        </a:rPr>
+                        <a:t>–</a:t>
+                      </a:r>
+                      <a:endParaRPr lang="en-US" sz="1200" dirty="0"/>
+                    </a:p>
+                  </a:txBody>
+                  <a:tcPr marL="91440" marR="91440" marT="53340" marB="53340" anchor="ctr">
+                    <a:lnL w="6350" cap="flat" cmpd="sng" algn="ctr">
+                      <a:solidFill>
+                        <a:schemeClr val="accent6"/>
+                      </a:solidFill>
+                      <a:prstDash val="solid"/>
+                      <a:round/>
+                      <a:headEnd type="none" w="med" len="med"/>
+                      <a:tailEnd type="none" w="med" len="med"/>
+                    </a:lnL>
+                    <a:lnR w="6350" cap="flat" cmpd="sng" algn="ctr">
+                      <a:solidFill>
+                        <a:schemeClr val="accent6"/>
+                      </a:solidFill>
+                      <a:prstDash val="solid"/>
+                      <a:round/>
+                      <a:headEnd type="none" w="med" len="med"/>
+                      <a:tailEnd type="none" w="med" len="med"/>
+                    </a:lnR>
+                    <a:lnT w="6350" cap="flat" cmpd="sng" algn="ctr">
+                      <a:solidFill>
+                        <a:schemeClr val="accent6"/>
+                      </a:solidFill>
+                      <a:prstDash val="solid"/>
+                      <a:round/>
+                      <a:headEnd type="none" w="med" len="med"/>
+                      <a:tailEnd type="none" w="med" len="med"/>
+                    </a:lnT>
+                    <a:lnB w="6350" cap="flat" cmpd="sng" algn="ctr">
+                      <a:solidFill>
+                        <a:schemeClr val="accent6"/>
+                      </a:solidFill>
+                      <a:prstDash val="solid"/>
+                      <a:round/>
+                      <a:headEnd type="none" w="med" len="med"/>
+                      <a:tailEnd type="none" w="med" len="med"/>
+                    </a:lnB>
+                    <a:solidFill>
+                      <a:schemeClr val="bg1"/>
+                    </a:solidFill>
+                  </a:tcPr>
+                </a:tc>
+                <a:tc>
+                  <a:txBody>
+                    <a:bodyPr/>
+                    <a:lstStyle/>
+                    <a:p>
+                      <a:pPr algn="ctr" indent="0" marL="0">
+                        <a:buNone/>
+                      </a:pPr>
+                      <a:r>
+                        <a:rPr lang="en-US" sz="1200" dirty="0">
+                          <a:solidFill>
+                            <a:schemeClr val="accent1"/>
+                          </a:solidFill>
+                        </a:rPr>
+                        <a:t>A/R</a:t>
+                      </a:r>
+                      <a:endParaRPr lang="en-US" sz="1200" dirty="0"/>
+                    </a:p>
+                  </a:txBody>
+                  <a:tcPr marL="91440" marR="91440" marT="53340" marB="53340" anchor="ctr">
+                    <a:lnL w="6350" cap="flat" cmpd="sng" algn="ctr">
+                      <a:solidFill>
+                        <a:schemeClr val="accent6"/>
+                      </a:solidFill>
+                      <a:prstDash val="solid"/>
+                      <a:round/>
+                      <a:headEnd type="none" w="med" len="med"/>
+                      <a:tailEnd type="none" w="med" len="med"/>
+                    </a:lnL>
+                    <a:lnR w="6350" cap="flat" cmpd="sng" algn="ctr">
+                      <a:solidFill>
+                        <a:schemeClr val="accent6"/>
+                      </a:solidFill>
+                      <a:prstDash val="solid"/>
+                      <a:round/>
+                      <a:headEnd type="none" w="med" len="med"/>
+                      <a:tailEnd type="none" w="med" len="med"/>
+                    </a:lnR>
+                    <a:lnT w="6350" cap="flat" cmpd="sng" algn="ctr">
+                      <a:solidFill>
+                        <a:schemeClr val="accent6"/>
+                      </a:solidFill>
+                      <a:prstDash val="solid"/>
+                      <a:round/>
+                      <a:headEnd type="none" w="med" len="med"/>
+                      <a:tailEnd type="none" w="med" len="med"/>
+                    </a:lnT>
+                    <a:lnB w="6350" cap="flat" cmpd="sng" algn="ctr">
+                      <a:solidFill>
+                        <a:schemeClr val="accent6"/>
+                      </a:solidFill>
+                      <a:prstDash val="solid"/>
+                      <a:round/>
+                      <a:headEnd type="none" w="med" len="med"/>
+                      <a:tailEnd type="none" w="med" len="med"/>
+                    </a:lnB>
+                    <a:solidFill>
+                      <a:schemeClr val="bg1"/>
+                    </a:solidFill>
+                  </a:tcPr>
+                </a:tc>
+                <a:tc>
+                  <a:txBody>
+                    <a:bodyPr/>
+                    <a:lstStyle/>
+                    <a:p>
+                      <a:pPr algn="ctr" indent="0" marL="0">
+                        <a:buNone/>
+                      </a:pPr>
+                      <a:r>
+                        <a:rPr lang="en-US" sz="1200" dirty="0">
+                          <a:solidFill>
+                            <a:schemeClr val="accent1"/>
+                          </a:solidFill>
+                        </a:rPr>
+                        <a:t>R</a:t>
+                      </a:r>
+                      <a:endParaRPr lang="en-US" sz="1200" dirty="0"/>
+                    </a:p>
+                  </a:txBody>
+                  <a:tcPr marL="91440" marR="91440" marT="53340" marB="53340" anchor="ctr">
+                    <a:lnL w="6350" cap="flat" cmpd="sng" algn="ctr">
+                      <a:solidFill>
+                        <a:schemeClr val="accent6"/>
+                      </a:solidFill>
+                      <a:prstDash val="solid"/>
+                      <a:round/>
+                      <a:headEnd type="none" w="med" len="med"/>
+                      <a:tailEnd type="none" w="med" len="med"/>
+                    </a:lnL>
+                    <a:lnR w="6350" cap="flat" cmpd="sng" algn="ctr">
+                      <a:solidFill>
+                        <a:schemeClr val="accent6"/>
+                      </a:solidFill>
+                      <a:prstDash val="solid"/>
+                      <a:round/>
+                      <a:headEnd type="none" w="med" len="med"/>
+                      <a:tailEnd type="none" w="med" len="med"/>
+                    </a:lnR>
+                    <a:lnT w="6350" cap="flat" cmpd="sng" algn="ctr">
+                      <a:solidFill>
+                        <a:schemeClr val="accent6"/>
+                      </a:solidFill>
+                      <a:prstDash val="solid"/>
+                      <a:round/>
+                      <a:headEnd type="none" w="med" len="med"/>
+                      <a:tailEnd type="none" w="med" len="med"/>
+                    </a:lnT>
+                    <a:lnB w="6350" cap="flat" cmpd="sng" algn="ctr">
+                      <a:solidFill>
+                        <a:schemeClr val="accent6"/>
+                      </a:solidFill>
+                      <a:prstDash val="solid"/>
+                      <a:round/>
+                      <a:headEnd type="none" w="med" len="med"/>
+                      <a:tailEnd type="none" w="med" len="med"/>
+                    </a:lnB>
+                    <a:solidFill>
+                      <a:schemeClr val="bg1"/>
+                    </a:solidFill>
+                  </a:tcPr>
+                </a:tc>
+                <a:tc>
+                  <a:txBody>
+                    <a:bodyPr/>
+                    <a:lstStyle/>
+                    <a:p>
+                      <a:pPr algn="ctr" indent="0" marL="0">
+                        <a:buNone/>
+                      </a:pPr>
+                      <a:r>
+                        <a:rPr lang="en-US" sz="1200" dirty="0">
+                          <a:solidFill>
+                            <a:schemeClr val="accent5"/>
+                          </a:solidFill>
+                        </a:rPr>
+                        <a:t>–</a:t>
+                      </a:r>
+                      <a:endParaRPr lang="en-US" sz="1200" dirty="0"/>
+                    </a:p>
+                  </a:txBody>
+                  <a:tcPr marL="91440" marR="91440" marT="53340" marB="53340" anchor="ctr">
+                    <a:lnL w="6350" cap="flat" cmpd="sng" algn="ctr">
+                      <a:solidFill>
+                        <a:schemeClr val="accent6"/>
+                      </a:solidFill>
+                      <a:prstDash val="solid"/>
+                      <a:round/>
+                      <a:headEnd type="none" w="med" len="med"/>
+                      <a:tailEnd type="none" w="med" len="med"/>
+                    </a:lnL>
+                    <a:lnR w="6350" cap="flat" cmpd="sng" algn="ctr">
+                      <a:solidFill>
+                        <a:schemeClr val="accent6"/>
+                      </a:solidFill>
+                      <a:prstDash val="solid"/>
+                      <a:round/>
+                      <a:headEnd type="none" w="med" len="med"/>
+                      <a:tailEnd type="none" w="med" len="med"/>
+                    </a:lnR>
+                    <a:lnT w="6350" cap="flat" cmpd="sng" algn="ctr">
+                      <a:solidFill>
+                        <a:schemeClr val="accent6"/>
+                      </a:solidFill>
+                      <a:prstDash val="solid"/>
+                      <a:round/>
+                      <a:headEnd type="none" w="med" len="med"/>
+                      <a:tailEnd type="none" w="med" len="med"/>
+                    </a:lnT>
+                    <a:lnB w="6350" cap="flat" cmpd="sng" algn="ctr">
+                      <a:solidFill>
+                        <a:schemeClr val="accent6"/>
+                      </a:solidFill>
+                      <a:prstDash val="solid"/>
+                      <a:round/>
+                      <a:headEnd type="none" w="med" len="med"/>
+                      <a:tailEnd type="none" w="med" len="med"/>
+                    </a:lnB>
+                    <a:solidFill>
+                      <a:schemeClr val="bg1"/>
+                    </a:solidFill>
+                  </a:tcPr>
+                </a:tc>
+                <a:tc>
+                  <a:txBody>
+                    <a:bodyPr/>
+                    <a:lstStyle/>
+                    <a:p>
+                      <a:pPr algn="l" indent="0" marL="0">
+                        <a:buNone/>
+                      </a:pPr>
+                      <a:r>
+                        <a:rPr lang="en-US" sz="1200" dirty="0">
+                          <a:solidFill>
+                            <a:schemeClr val="accent2"/>
+                          </a:solidFill>
+                        </a:rPr>
+                        <a:t>[Twice a year]</a:t>
                       </a:r>
                       <a:endParaRPr lang="en-US" sz="1200" dirty="0"/>
                     </a:p>
@@ -8362,7 +8827,7 @@
                             <a:schemeClr val="accent5"/>
                           </a:solidFill>
                         </a:rPr>
-                        <a:t>Sensitive changes, duplicates, what the app can’t</a:t>
+                        <a:t>Sensitive changes, duplicates, what the app can’t; samples</a:t>
                       </a:r>
                       <a:endParaRPr lang="en-US" sz="1200" dirty="0"/>
                     </a:p>
@@ -9585,8 +10050,8 @@
         </p:nvSpPr>
         <p:spPr>
           <a:xfrm>
-            <a:off x="406359" y="4254429"/>
-            <a:ext cx="11417290" cy="198059"/>
+            <a:off x="406359" y="4580595"/>
+            <a:ext cx="11417290" cy="396118"/>
           </a:xfrm>
           <a:prstGeom prst="rect">
             <a:avLst/>
@@ -9708,7 +10173,7 @@
                   <a:schemeClr val="accent5"/>
                 </a:solidFill>
               </a:rPr>
-              <a:t> informed. Shaded: an attribute owner can hand this to delegates. Agents do much of the work but are never accountable.</a:t>
+              <a:t> informed. The GPDO stays accountable for the whole domain; A is who answers for each decision. Shaded: an attribute owner can hand this to delegates. Agents do much of the work but are never accountable.</a:t>
             </a:r>
             <a:endParaRPr lang="en-US" sz="1200" dirty="0"/>
           </a:p>
@@ -9722,7 +10187,7 @@
         </p:nvSpPr>
         <p:spPr>
           <a:xfrm>
-            <a:off x="406359" y="4566696"/>
+            <a:off x="406359" y="5091013"/>
             <a:ext cx="11379159" cy="1269644"/>
           </a:xfrm>
           <a:prstGeom prst="roundRect">
@@ -9749,7 +10214,7 @@
         </p:nvSpPr>
         <p:spPr>
           <a:xfrm>
-            <a:off x="577809" y="4694895"/>
+            <a:off x="577809" y="5219212"/>
             <a:ext cx="843351" cy="182880"/>
           </a:xfrm>
           <a:prstGeom prst="rect">
@@ -9788,7 +10253,7 @@
         </p:nvSpPr>
         <p:spPr>
           <a:xfrm>
-            <a:off x="9098737" y="4687397"/>
+            <a:off x="9098737" y="5211623"/>
             <a:ext cx="2553462" cy="198059"/>
           </a:xfrm>
           <a:prstGeom prst="rect">
@@ -9855,7 +10320,7 @@
         </p:nvSpPr>
         <p:spPr>
           <a:xfrm>
-            <a:off x="577809" y="4923495"/>
+            <a:off x="577809" y="5447812"/>
             <a:ext cx="5372100" cy="792145"/>
           </a:xfrm>
           <a:prstGeom prst="rect">
@@ -9949,7 +10414,7 @@
         </p:nvSpPr>
         <p:spPr>
           <a:xfrm>
-            <a:off x="6280191" y="4923495"/>
+            <a:off x="6280191" y="5447812"/>
             <a:ext cx="5372100" cy="792145"/>
           </a:xfrm>
           <a:prstGeom prst="rect">
@@ -10168,11 +10633,11 @@
         <p:spPr>
           <a:xfrm>
             <a:off x="406359" y="807598"/>
-            <a:ext cx="6881409" cy="1452433"/>
+            <a:ext cx="6881409" cy="1650492"/>
           </a:xfrm>
           <a:prstGeom prst="roundRect">
             <a:avLst>
-              <a:gd name="adj" fmla="val 6995"/>
+              <a:gd name="adj" fmla="val 6156"/>
             </a:avLst>
           </a:prstGeom>
           <a:solidFill>
@@ -10189,7 +10654,7 @@
         </p:nvSpPr>
         <p:spPr>
           <a:xfrm>
-            <a:off x="634959" y="1156716"/>
+            <a:off x="634959" y="1255746"/>
             <a:ext cx="6462339" cy="182880"/>
           </a:xfrm>
           <a:prstGeom prst="rect">
@@ -10228,7 +10693,7 @@
         </p:nvSpPr>
         <p:spPr>
           <a:xfrm>
-            <a:off x="634959" y="1415766"/>
+            <a:off x="634959" y="1514795"/>
             <a:ext cx="6462339" cy="495330"/>
           </a:xfrm>
           <a:prstGeom prst="rect">
@@ -10271,11 +10736,11 @@
         <p:spPr>
           <a:xfrm>
             <a:off x="7427488" y="807598"/>
-            <a:ext cx="4358122" cy="1452433"/>
+            <a:ext cx="4358122" cy="1650492"/>
           </a:xfrm>
           <a:prstGeom prst="roundRect">
             <a:avLst>
-              <a:gd name="adj" fmla="val 6995"/>
+              <a:gd name="adj" fmla="val 6156"/>
             </a:avLst>
           </a:prstGeom>
           <a:solidFill>
@@ -10330,14 +10795,14 @@
       </p:sp>
       <p:sp>
         <p:nvSpPr>
-          <p:cNvPr id="10" name="Text: Never approve, confirm, delete or grant "/>
+          <p:cNvPr id="10" name="Text: Never approve, confirm or grant access N"/>
           <p:cNvSpPr txBox="1"/>
           <p:nvPr/>
         </p:nvSpPr>
         <p:spPr>
           <a:xfrm>
             <a:off x="7598938" y="1149218"/>
-            <a:ext cx="4053261" cy="990204"/>
+            <a:ext cx="4053261" cy="1188263"/>
           </a:xfrm>
           <a:prstGeom prst="rect">
             <a:avLst/>
@@ -10362,7 +10827,7 @@
                   <a:schemeClr val="tx1"/>
                 </a:solidFill>
               </a:rPr>
-              <a:t>Never approve, confirm, delete or grant access</a:t>
+              <a:t>Never approve, confirm or grant access</a:t>
             </a:r>
             <a:endParaRPr lang="en-US" sz="1200" dirty="0"/>
           </a:p>
@@ -10380,7 +10845,7 @@
                   <a:schemeClr val="tx1"/>
                 </a:solidFill>
               </a:rPr>
-              <a:t>Start by proposing; a person decides</a:t>
+              <a:t>Never delete records or change sensitive fields</a:t>
             </a:r>
             <a:endParaRPr lang="en-US" sz="1200" dirty="0"/>
           </a:p>
@@ -10398,7 +10863,7 @@
                   <a:schemeClr val="tx1"/>
                 </a:solidFill>
               </a:rPr>
-              <a:t>Owners approve each move up a level</a:t>
+              <a:t>Start by proposing; later, only routine changes owners allow</a:t>
             </a:r>
             <a:endParaRPr lang="en-US" sz="1200" dirty="0"/>
           </a:p>
@@ -10434,7 +10899,25 @@
                   <a:schemeClr val="tx1"/>
                 </a:solidFill>
               </a:rPr>
-              <a:t>AI model approved first; trade secrets stay in controlled AI</a:t>
+              <a:t>AI models approved by the platform owner</a:t>
+            </a:r>
+            <a:endParaRPr lang="en-US" sz="1200" dirty="0"/>
+          </a:p>
+          <a:p>
+            <a:pPr algn="l" marL="165100" indent="-165100">
+              <a:lnSpc>
+                <a:spcPts val="1560"/>
+              </a:lnSpc>
+              <a:buSzPct val="100000"/>
+              <a:buChar char="•"/>
+            </a:pPr>
+            <a:r>
+              <a:rPr lang="en-US" sz="1200" dirty="0">
+                <a:solidFill>
+                  <a:schemeClr val="tx1"/>
+                </a:solidFill>
+              </a:rPr>
+              <a:t>Trade secrets stay in AI the organisation controls</a:t>
             </a:r>
             <a:endParaRPr lang="en-US" sz="1200" dirty="0"/>
           </a:p>
@@ -10448,7 +10931,7 @@
         </p:nvSpPr>
         <p:spPr>
           <a:xfrm>
-            <a:off x="406359" y="2374422"/>
+            <a:off x="406359" y="2572482"/>
             <a:ext cx="3594141" cy="182880"/>
           </a:xfrm>
           <a:prstGeom prst="rect">
@@ -10487,7 +10970,7 @@
         </p:nvSpPr>
         <p:spPr>
           <a:xfrm>
-            <a:off x="406359" y="2620762"/>
+            <a:off x="406359" y="2818821"/>
             <a:ext cx="3556010" cy="1404153"/>
           </a:xfrm>
           <a:prstGeom prst="roundRect">
@@ -10514,7 +10997,7 @@
         </p:nvSpPr>
         <p:spPr>
           <a:xfrm>
-            <a:off x="539770" y="2728752"/>
+            <a:off x="539770" y="2926720"/>
             <a:ext cx="3327410" cy="1188263"/>
           </a:xfrm>
           <a:prstGeom prst="rect">
@@ -10594,7 +11077,7 @@
                   <a:schemeClr val="tx1"/>
                 </a:solidFill>
               </a:rPr>
-              <a:t>Approves what owners have approved</a:t>
+              <a:t>Approves the routine requests owners allow</a:t>
             </a:r>
             <a:endParaRPr lang="en-US" sz="1200" dirty="0"/>
           </a:p>
@@ -10644,7 +11127,7 @@
         </p:nvSpPr>
         <p:spPr>
           <a:xfrm>
-            <a:off x="4025920" y="3247217"/>
+            <a:off x="4025920" y="3445276"/>
             <a:ext cx="254020" cy="152430"/>
           </a:xfrm>
           <a:prstGeom prst="rightArrow">
@@ -10664,7 +11147,7 @@
         </p:nvSpPr>
         <p:spPr>
           <a:xfrm>
-            <a:off x="4343400" y="2374422"/>
+            <a:off x="4343400" y="2572482"/>
             <a:ext cx="3594141" cy="182880"/>
           </a:xfrm>
           <a:prstGeom prst="rect">
@@ -10703,7 +11186,7 @@
         </p:nvSpPr>
         <p:spPr>
           <a:xfrm>
-            <a:off x="4343400" y="2620762"/>
+            <a:off x="4343400" y="2818821"/>
             <a:ext cx="3556010" cy="1404153"/>
           </a:xfrm>
           <a:prstGeom prst="roundRect">
@@ -10730,7 +11213,7 @@
         </p:nvSpPr>
         <p:spPr>
           <a:xfrm>
-            <a:off x="4476720" y="2728752"/>
+            <a:off x="4476720" y="2926720"/>
             <a:ext cx="3327410" cy="792145"/>
           </a:xfrm>
           <a:prstGeom prst="rect">
@@ -10806,7 +11289,7 @@
         </p:nvSpPr>
         <p:spPr>
           <a:xfrm>
-            <a:off x="7962870" y="3247217"/>
+            <a:off x="7962870" y="3445276"/>
             <a:ext cx="254020" cy="152430"/>
           </a:xfrm>
           <a:prstGeom prst="rightArrow">
@@ -10826,7 +11309,7 @@
         </p:nvSpPr>
         <p:spPr>
           <a:xfrm>
-            <a:off x="8280441" y="2374422"/>
+            <a:off x="8280441" y="2572482"/>
             <a:ext cx="3543300" cy="182880"/>
           </a:xfrm>
           <a:prstGeom prst="rect">
@@ -10865,7 +11348,7 @@
         </p:nvSpPr>
         <p:spPr>
           <a:xfrm>
-            <a:off x="8280441" y="2620762"/>
+            <a:off x="8280441" y="2818821"/>
             <a:ext cx="3505170" cy="1404153"/>
           </a:xfrm>
           <a:prstGeom prst="roundRect">
@@ -10892,7 +11375,7 @@
         </p:nvSpPr>
         <p:spPr>
           <a:xfrm>
-            <a:off x="8413760" y="2728752"/>
+            <a:off x="8413760" y="2926720"/>
             <a:ext cx="3276570" cy="792145"/>
           </a:xfrm>
           <a:prstGeom prst="rect">
@@ -10986,7 +11469,7 @@
         </p:nvSpPr>
         <p:spPr>
           <a:xfrm>
-            <a:off x="406359" y="4139214"/>
+            <a:off x="406359" y="4337274"/>
             <a:ext cx="11417290" cy="182880"/>
           </a:xfrm>
           <a:prstGeom prst="rect">
@@ -11025,7 +11508,7 @@
         </p:nvSpPr>
         <p:spPr>
           <a:xfrm>
-            <a:off x="406359" y="4385554"/>
+            <a:off x="406359" y="4583613"/>
             <a:ext cx="2184410" cy="1442283"/>
           </a:xfrm>
           <a:prstGeom prst="roundRect">
@@ -11047,7 +11530,7 @@
         </p:nvSpPr>
         <p:spPr>
           <a:xfrm>
-            <a:off x="444490" y="4385554"/>
+            <a:off x="444490" y="4583613"/>
             <a:ext cx="2146280" cy="1442283"/>
           </a:xfrm>
           <a:prstGeom prst="roundRect">
@@ -11069,7 +11552,7 @@
         </p:nvSpPr>
         <p:spPr>
           <a:xfrm>
-            <a:off x="571500" y="4487144"/>
+            <a:off x="571500" y="4685203"/>
             <a:ext cx="1930390" cy="198059"/>
           </a:xfrm>
           <a:prstGeom prst="rect">
@@ -11108,7 +11591,7 @@
         </p:nvSpPr>
         <p:spPr>
           <a:xfrm>
-            <a:off x="571500" y="4710623"/>
+            <a:off x="571500" y="4908682"/>
             <a:ext cx="1930390" cy="198059"/>
           </a:xfrm>
           <a:prstGeom prst="rect">
@@ -11147,7 +11630,7 @@
         </p:nvSpPr>
         <p:spPr>
           <a:xfrm>
-            <a:off x="571500" y="4934011"/>
+            <a:off x="571500" y="5132070"/>
             <a:ext cx="1930390" cy="594086"/>
           </a:xfrm>
           <a:prstGeom prst="rect">
@@ -11186,7 +11669,7 @@
         </p:nvSpPr>
         <p:spPr>
           <a:xfrm>
-            <a:off x="2705070" y="4385554"/>
+            <a:off x="2705070" y="4583613"/>
             <a:ext cx="2184410" cy="1442283"/>
           </a:xfrm>
           <a:prstGeom prst="roundRect">
@@ -11208,7 +11691,7 @@
         </p:nvSpPr>
         <p:spPr>
           <a:xfrm>
-            <a:off x="2743200" y="4385554"/>
+            <a:off x="2743200" y="4583613"/>
             <a:ext cx="2146280" cy="1442283"/>
           </a:xfrm>
           <a:prstGeom prst="roundRect">
@@ -11230,7 +11713,7 @@
         </p:nvSpPr>
         <p:spPr>
           <a:xfrm>
-            <a:off x="2870210" y="4487144"/>
+            <a:off x="2870210" y="4685203"/>
             <a:ext cx="1930390" cy="198059"/>
           </a:xfrm>
           <a:prstGeom prst="rect">
@@ -11269,7 +11752,7 @@
         </p:nvSpPr>
         <p:spPr>
           <a:xfrm>
-            <a:off x="2870210" y="4710623"/>
+            <a:off x="2870210" y="4908682"/>
             <a:ext cx="1930390" cy="198059"/>
           </a:xfrm>
           <a:prstGeom prst="rect">
@@ -11308,7 +11791,7 @@
         </p:nvSpPr>
         <p:spPr>
           <a:xfrm>
-            <a:off x="2870210" y="4934011"/>
+            <a:off x="2870210" y="5132070"/>
             <a:ext cx="1930390" cy="594086"/>
           </a:xfrm>
           <a:prstGeom prst="rect">
@@ -11347,7 +11830,7 @@
         </p:nvSpPr>
         <p:spPr>
           <a:xfrm>
-            <a:off x="5003780" y="4385554"/>
+            <a:off x="5003780" y="4583613"/>
             <a:ext cx="2184410" cy="1442283"/>
           </a:xfrm>
           <a:prstGeom prst="roundRect">
@@ -11369,7 +11852,7 @@
         </p:nvSpPr>
         <p:spPr>
           <a:xfrm>
-            <a:off x="5041910" y="4385554"/>
+            <a:off x="5041910" y="4583613"/>
             <a:ext cx="2146280" cy="1442283"/>
           </a:xfrm>
           <a:prstGeom prst="roundRect">
@@ -11391,7 +11874,7 @@
         </p:nvSpPr>
         <p:spPr>
           <a:xfrm>
-            <a:off x="5168920" y="4487144"/>
+            <a:off x="5168920" y="4685203"/>
             <a:ext cx="1930390" cy="198059"/>
           </a:xfrm>
           <a:prstGeom prst="rect">
@@ -11430,7 +11913,7 @@
         </p:nvSpPr>
         <p:spPr>
           <a:xfrm>
-            <a:off x="5168920" y="4710623"/>
+            <a:off x="5168920" y="4908682"/>
             <a:ext cx="1930390" cy="198059"/>
           </a:xfrm>
           <a:prstGeom prst="rect">
@@ -11469,7 +11952,7 @@
         </p:nvSpPr>
         <p:spPr>
           <a:xfrm>
-            <a:off x="5168920" y="4934011"/>
+            <a:off x="5168920" y="5132070"/>
             <a:ext cx="1930390" cy="594086"/>
           </a:xfrm>
           <a:prstGeom prst="rect">
@@ -11508,7 +11991,7 @@
         </p:nvSpPr>
         <p:spPr>
           <a:xfrm>
-            <a:off x="7302490" y="4385554"/>
+            <a:off x="7302490" y="4583613"/>
             <a:ext cx="2184410" cy="1442283"/>
           </a:xfrm>
           <a:prstGeom prst="roundRect">
@@ -11530,7 +12013,7 @@
         </p:nvSpPr>
         <p:spPr>
           <a:xfrm>
-            <a:off x="7340620" y="4385554"/>
+            <a:off x="7340620" y="4583613"/>
             <a:ext cx="2146280" cy="1442283"/>
           </a:xfrm>
           <a:prstGeom prst="roundRect">
@@ -11552,7 +12035,7 @@
         </p:nvSpPr>
         <p:spPr>
           <a:xfrm>
-            <a:off x="7467630" y="4487144"/>
+            <a:off x="7467630" y="4685203"/>
             <a:ext cx="1930390" cy="198059"/>
           </a:xfrm>
           <a:prstGeom prst="rect">
@@ -11591,7 +12074,7 @@
         </p:nvSpPr>
         <p:spPr>
           <a:xfrm>
-            <a:off x="7467630" y="4710623"/>
+            <a:off x="7467630" y="4908682"/>
             <a:ext cx="1930390" cy="396118"/>
           </a:xfrm>
           <a:prstGeom prst="rect">
@@ -11630,7 +12113,7 @@
         </p:nvSpPr>
         <p:spPr>
           <a:xfrm>
-            <a:off x="7467630" y="5132070"/>
+            <a:off x="7467630" y="5330129"/>
             <a:ext cx="1930390" cy="594086"/>
           </a:xfrm>
           <a:prstGeom prst="rect">
@@ -11669,7 +12152,7 @@
         </p:nvSpPr>
         <p:spPr>
           <a:xfrm>
-            <a:off x="9601200" y="4385554"/>
+            <a:off x="9601200" y="4583613"/>
             <a:ext cx="2184410" cy="1442283"/>
           </a:xfrm>
           <a:prstGeom prst="roundRect">
@@ -11691,7 +12174,7 @@
         </p:nvSpPr>
         <p:spPr>
           <a:xfrm>
-            <a:off x="9639330" y="4385554"/>
+            <a:off x="9639330" y="4583613"/>
             <a:ext cx="2146280" cy="1442283"/>
           </a:xfrm>
           <a:prstGeom prst="roundRect">
@@ -11713,7 +12196,7 @@
         </p:nvSpPr>
         <p:spPr>
           <a:xfrm>
-            <a:off x="9766341" y="4487144"/>
+            <a:off x="9766341" y="4685203"/>
             <a:ext cx="1930390" cy="198059"/>
           </a:xfrm>
           <a:prstGeom prst="rect">
@@ -11752,7 +12235,7 @@
         </p:nvSpPr>
         <p:spPr>
           <a:xfrm>
-            <a:off x="9766341" y="4710623"/>
+            <a:off x="9766341" y="4908682"/>
             <a:ext cx="1930390" cy="198059"/>
           </a:xfrm>
           <a:prstGeom prst="rect">
@@ -11791,7 +12274,7 @@
         </p:nvSpPr>
         <p:spPr>
           <a:xfrm>
-            <a:off x="9766341" y="4934011"/>
+            <a:off x="9766341" y="5132070"/>
             <a:ext cx="1930390" cy="594086"/>
           </a:xfrm>
           <a:prstGeom prst="rect">

</xml_diff>

<commit_message>
Say on the cover that owners approve what the app doesn't
Attribute owners set the checks and what the app may approve; the app
approves only that, and owners approve the rest, prepared by agents.

Co-Authored-By: Claude Opus 5.5 <noreply@anthropic.com>
Claude-Session: https://claude.ai/code/session_01PCy2Xpp9YsL4rxbq6m4G9b
</commit_message>
<xml_diff>
--- a/deck/lean-data-governance.pptx
+++ b/deck/lean-data-governance.pptx
@@ -111,18 +111,18 @@
   <p:extLst>
     <p:ext uri="{521415D9-36F7-43E2-AB2F-B90AF26B5E84}">
       <p14:sectionLst xmlns:p14="http://schemas.microsoft.com/office/powerpoint/2010/main">
-        <p14:section name="Framework" id="{3dbb6ac4-bc74-86e3-28c4-1b2015a637c2}">
+        <p14:section name="Framework" id="{4526a04f-3f95-fcbb-4a60-d342ef4cdb0b}">
           <p14:sldIdLst>
             <p14:sldId id="256"/>
           </p14:sldIdLst>
         </p14:section>
-        <p14:section name="Ownership and rules" id="{d15ff068-7662-21e7-3538-63adf81c0c1c}">
+        <p14:section name="Ownership and rules" id="{4c8bb24e-b5b4-bdc6-05d5-9cc7279e8381}">
           <p14:sldIdLst>
             <p14:sldId id="257"/>
             <p14:sldId id="258"/>
           </p14:sldIdLst>
         </p14:section>
-        <p14:section name="Operating model" id="{93c61eea-a076-f5b8-1f28-c43ada9bdfe8}">
+        <p14:section name="Operating model" id="{2a933a04-ee3b-cb9d-f87a-7d1a0d43611d}">
           <p14:sldIdLst>
             <p14:sldId id="259"/>
             <p14:sldId id="260"/>
@@ -1869,11 +1869,11 @@
         <p:spPr>
           <a:xfrm>
             <a:off x="406359" y="2498964"/>
-            <a:ext cx="3429000" cy="614477"/>
+            <a:ext cx="3429000" cy="561167"/>
           </a:xfrm>
           <a:prstGeom prst="roundRect">
             <a:avLst>
-              <a:gd name="adj" fmla="val 12401"/>
+              <a:gd name="adj" fmla="val 13579"/>
             </a:avLst>
           </a:prstGeom>
           <a:solidFill>
@@ -1895,7 +1895,7 @@
         </p:nvSpPr>
         <p:spPr>
           <a:xfrm>
-            <a:off x="539770" y="2608052"/>
+            <a:off x="539770" y="2581443"/>
             <a:ext cx="3200400" cy="396118"/>
           </a:xfrm>
           <a:prstGeom prst="rect">
@@ -1948,12 +1948,12 @@
         </p:nvSpPr>
         <p:spPr>
           <a:xfrm>
-            <a:off x="406359" y="3176900"/>
-            <a:ext cx="3429000" cy="614568"/>
+            <a:off x="406359" y="3123590"/>
+            <a:ext cx="3429000" cy="561167"/>
           </a:xfrm>
           <a:prstGeom prst="roundRect">
             <a:avLst>
-              <a:gd name="adj" fmla="val 12399"/>
+              <a:gd name="adj" fmla="val 13579"/>
             </a:avLst>
           </a:prstGeom>
           <a:solidFill>
@@ -1975,7 +1975,7 @@
         </p:nvSpPr>
         <p:spPr>
           <a:xfrm>
-            <a:off x="539770" y="3286171"/>
+            <a:off x="539770" y="3206161"/>
             <a:ext cx="3200400" cy="396118"/>
           </a:xfrm>
           <a:prstGeom prst="rect">
@@ -2028,12 +2028,12 @@
         </p:nvSpPr>
         <p:spPr>
           <a:xfrm>
-            <a:off x="406359" y="3854928"/>
-            <a:ext cx="3429000" cy="614477"/>
+            <a:off x="406359" y="3748308"/>
+            <a:ext cx="3429000" cy="561167"/>
           </a:xfrm>
           <a:prstGeom prst="roundRect">
             <a:avLst>
-              <a:gd name="adj" fmla="val 12401"/>
+              <a:gd name="adj" fmla="val 13579"/>
             </a:avLst>
           </a:prstGeom>
           <a:solidFill>
@@ -2055,7 +2055,7 @@
         </p:nvSpPr>
         <p:spPr>
           <a:xfrm>
-            <a:off x="539770" y="3964107"/>
+            <a:off x="539770" y="3830879"/>
             <a:ext cx="3200400" cy="396118"/>
           </a:xfrm>
           <a:prstGeom prst="rect">
@@ -2108,7 +2108,7 @@
         </p:nvSpPr>
         <p:spPr>
           <a:xfrm>
-            <a:off x="3898910" y="2757465"/>
+            <a:off x="3898910" y="2730764"/>
             <a:ext cx="254020" cy="152430"/>
           </a:xfrm>
           <a:prstGeom prst="rightArrow">
@@ -2128,7 +2128,7 @@
         </p:nvSpPr>
         <p:spPr>
           <a:xfrm>
-            <a:off x="3898910" y="3411718"/>
+            <a:off x="3898910" y="3331799"/>
             <a:ext cx="254020" cy="152430"/>
           </a:xfrm>
           <a:prstGeom prst="rightArrow">
@@ -2148,7 +2148,7 @@
         </p:nvSpPr>
         <p:spPr>
           <a:xfrm>
-            <a:off x="3898910" y="4066062"/>
+            <a:off x="3898910" y="3932743"/>
             <a:ext cx="254020" cy="152430"/>
           </a:xfrm>
           <a:prstGeom prst="rightArrow">
@@ -2208,11 +2208,11 @@
         <p:spPr>
           <a:xfrm>
             <a:off x="4216390" y="2498964"/>
-            <a:ext cx="3556010" cy="1970441"/>
+            <a:ext cx="3556010" cy="1810512"/>
           </a:xfrm>
           <a:prstGeom prst="roundRect">
             <a:avLst>
-              <a:gd name="adj" fmla="val 5156"/>
+              <a:gd name="adj" fmla="val 5612"/>
             </a:avLst>
           </a:prstGeom>
           <a:solidFill>
@@ -2229,7 +2229,7 @@
         </p:nvSpPr>
         <p:spPr>
           <a:xfrm>
-            <a:off x="4419570" y="2761031"/>
+            <a:off x="4419570" y="2681112"/>
             <a:ext cx="3187690" cy="476220"/>
           </a:xfrm>
           <a:prstGeom prst="rect">
@@ -2271,7 +2271,7 @@
         </p:nvSpPr>
         <p:spPr>
           <a:xfrm>
-            <a:off x="4419570" y="3326221"/>
+            <a:off x="4419570" y="3246211"/>
             <a:ext cx="3187690" cy="396118"/>
           </a:xfrm>
           <a:prstGeom prst="rect">
@@ -2408,7 +2408,7 @@
         </p:nvSpPr>
         <p:spPr>
           <a:xfrm>
-            <a:off x="4419570" y="3811219"/>
+            <a:off x="4419570" y="3731209"/>
             <a:ext cx="3187690" cy="396118"/>
           </a:xfrm>
           <a:prstGeom prst="rect">
@@ -2447,7 +2447,7 @@
         </p:nvSpPr>
         <p:spPr>
           <a:xfrm>
-            <a:off x="7835859" y="2757465"/>
+            <a:off x="7835859" y="2730764"/>
             <a:ext cx="254020" cy="152430"/>
           </a:xfrm>
           <a:prstGeom prst="rightArrow">
@@ -2467,7 +2467,7 @@
         </p:nvSpPr>
         <p:spPr>
           <a:xfrm>
-            <a:off x="7835859" y="3411718"/>
+            <a:off x="7835859" y="3331799"/>
             <a:ext cx="254020" cy="152430"/>
           </a:xfrm>
           <a:prstGeom prst="rightArrow">
@@ -2487,7 +2487,7 @@
         </p:nvSpPr>
         <p:spPr>
           <a:xfrm>
-            <a:off x="7835859" y="4066062"/>
+            <a:off x="7835859" y="3932743"/>
             <a:ext cx="254020" cy="152430"/>
           </a:xfrm>
           <a:prstGeom prst="rightArrow">
@@ -2547,11 +2547,11 @@
         <p:spPr>
           <a:xfrm>
             <a:off x="8153430" y="2498964"/>
-            <a:ext cx="3632180" cy="548457"/>
+            <a:ext cx="3632180" cy="561167"/>
           </a:xfrm>
           <a:prstGeom prst="roundRect">
             <a:avLst>
-              <a:gd name="adj" fmla="val 13894"/>
+              <a:gd name="adj" fmla="val 13579"/>
             </a:avLst>
           </a:prstGeom>
           <a:solidFill>
@@ -2569,11 +2569,11 @@
         <p:spPr>
           <a:xfrm>
             <a:off x="8191470" y="2498964"/>
-            <a:ext cx="3594141" cy="548457"/>
+            <a:ext cx="3594141" cy="561167"/>
           </a:xfrm>
           <a:prstGeom prst="roundRect">
             <a:avLst>
-              <a:gd name="adj" fmla="val 13894"/>
+              <a:gd name="adj" fmla="val 13579"/>
             </a:avLst>
           </a:prstGeom>
           <a:solidFill>
@@ -2590,7 +2590,7 @@
         </p:nvSpPr>
         <p:spPr>
           <a:xfrm>
-            <a:off x="8318480" y="2575133"/>
+            <a:off x="8318480" y="2581443"/>
             <a:ext cx="3378159" cy="396118"/>
           </a:xfrm>
           <a:prstGeom prst="rect">
@@ -2629,7 +2629,7 @@
                   <a:schemeClr val="tx1"/>
                 </a:solidFill>
               </a:rPr>
-              <a:t> GPDOs delegate parts to attribute owners, who set the app’s settings and decide what it can’t.</a:t>
+              <a:t> GPDOs delegate parts to attribute owners, who set the checks and what the app may approve.</a:t>
             </a:r>
             <a:endParaRPr lang="en-US" sz="1200" dirty="0"/>
           </a:p>
@@ -2643,12 +2643,12 @@
         </p:nvSpPr>
         <p:spPr>
           <a:xfrm>
-            <a:off x="8153430" y="3110880"/>
-            <a:ext cx="3632180" cy="746516"/>
+            <a:off x="8153430" y="3123590"/>
+            <a:ext cx="3632180" cy="561167"/>
           </a:xfrm>
           <a:prstGeom prst="roundRect">
             <a:avLst>
-              <a:gd name="adj" fmla="val 10207"/>
+              <a:gd name="adj" fmla="val 13579"/>
             </a:avLst>
           </a:prstGeom>
           <a:solidFill>
@@ -2665,12 +2665,12 @@
         </p:nvSpPr>
         <p:spPr>
           <a:xfrm>
-            <a:off x="8191470" y="3110880"/>
-            <a:ext cx="3594141" cy="746516"/>
+            <a:off x="8191470" y="3123590"/>
+            <a:ext cx="3594141" cy="561167"/>
           </a:xfrm>
           <a:prstGeom prst="roundRect">
             <a:avLst>
-              <a:gd name="adj" fmla="val 10207"/>
+              <a:gd name="adj" fmla="val 13579"/>
             </a:avLst>
           </a:prstGeom>
           <a:solidFill>
@@ -2681,14 +2681,14 @@
       </p:sp>
       <p:sp>
         <p:nvSpPr>
-          <p:cNvPr id="37" name="Text: 2. Enforce. The app checks every request"/>
+          <p:cNvPr id="37" name="Text: 2. Enforce. The app approves what owners"/>
           <p:cNvSpPr txBox="1"/>
           <p:nvPr/>
         </p:nvSpPr>
         <p:spPr>
           <a:xfrm>
-            <a:off x="8318480" y="3187141"/>
-            <a:ext cx="3378159" cy="594086"/>
+            <a:off x="8318480" y="3206161"/>
+            <a:ext cx="3378159" cy="396118"/>
           </a:xfrm>
           <a:prstGeom prst="rect">
             <a:avLst/>
@@ -2726,7 +2726,7 @@
                   <a:schemeClr val="tx1"/>
                 </a:solidFill>
               </a:rPr>
-              <a:t> The app checks every request and approves what owners allow; agents prepare the rest.</a:t>
+              <a:t> The app approves what owners allow. Owners approve the rest, prepared by agents.</a:t>
             </a:r>
             <a:endParaRPr lang="en-US" sz="1200" dirty="0"/>
           </a:p>
@@ -2740,12 +2740,12 @@
         </p:nvSpPr>
         <p:spPr>
           <a:xfrm>
-            <a:off x="8153430" y="3920947"/>
-            <a:ext cx="3632180" cy="548457"/>
+            <a:off x="8153430" y="3748308"/>
+            <a:ext cx="3632180" cy="561167"/>
           </a:xfrm>
           <a:prstGeom prst="roundRect">
             <a:avLst>
-              <a:gd name="adj" fmla="val 13894"/>
+              <a:gd name="adj" fmla="val 13579"/>
             </a:avLst>
           </a:prstGeom>
           <a:solidFill>
@@ -2762,12 +2762,12 @@
         </p:nvSpPr>
         <p:spPr>
           <a:xfrm>
-            <a:off x="8191470" y="3920947"/>
-            <a:ext cx="3594141" cy="548457"/>
+            <a:off x="8191470" y="3748308"/>
+            <a:ext cx="3594141" cy="561167"/>
           </a:xfrm>
           <a:prstGeom prst="roundRect">
             <a:avLst>
-              <a:gd name="adj" fmla="val 13894"/>
+              <a:gd name="adj" fmla="val 13579"/>
             </a:avLst>
           </a:prstGeom>
           <a:solidFill>
@@ -2784,7 +2784,7 @@
         </p:nvSpPr>
         <p:spPr>
           <a:xfrm>
-            <a:off x="8318480" y="3997117"/>
+            <a:off x="8318480" y="3830879"/>
             <a:ext cx="3378159" cy="396118"/>
           </a:xfrm>
           <a:prstGeom prst="rect">
@@ -2837,7 +2837,7 @@
         </p:nvSpPr>
         <p:spPr>
           <a:xfrm>
-            <a:off x="406359" y="4583704"/>
+            <a:off x="406359" y="4423776"/>
             <a:ext cx="3699845" cy="1848551"/>
           </a:xfrm>
           <a:prstGeom prst="roundRect">
@@ -2864,7 +2864,7 @@
         </p:nvSpPr>
         <p:spPr>
           <a:xfrm>
-            <a:off x="577809" y="4704314"/>
+            <a:off x="577809" y="4544385"/>
             <a:ext cx="3395076" cy="182880"/>
           </a:xfrm>
           <a:prstGeom prst="rect">
@@ -2903,7 +2903,7 @@
         </p:nvSpPr>
         <p:spPr>
           <a:xfrm>
-            <a:off x="577809" y="4925324"/>
+            <a:off x="577809" y="4765396"/>
             <a:ext cx="3395076" cy="990204"/>
           </a:xfrm>
           <a:prstGeom prst="rect">
@@ -2997,7 +2997,7 @@
         </p:nvSpPr>
         <p:spPr>
           <a:xfrm>
-            <a:off x="4245925" y="4583704"/>
+            <a:off x="4245925" y="4423776"/>
             <a:ext cx="3699937" cy="1848551"/>
           </a:xfrm>
           <a:prstGeom prst="roundRect">
@@ -3024,7 +3024,7 @@
         </p:nvSpPr>
         <p:spPr>
           <a:xfrm>
-            <a:off x="4417375" y="4704314"/>
+            <a:off x="4417375" y="4544385"/>
             <a:ext cx="3395167" cy="182880"/>
           </a:xfrm>
           <a:prstGeom prst="rect">
@@ -3063,7 +3063,7 @@
         </p:nvSpPr>
         <p:spPr>
           <a:xfrm>
-            <a:off x="4417375" y="4925324"/>
+            <a:off x="4417375" y="4765396"/>
             <a:ext cx="3395167" cy="1386322"/>
           </a:xfrm>
           <a:prstGeom prst="rect">
@@ -3211,7 +3211,7 @@
         </p:nvSpPr>
         <p:spPr>
           <a:xfrm>
-            <a:off x="8085673" y="4583704"/>
+            <a:off x="8085673" y="4423776"/>
             <a:ext cx="3699937" cy="1848551"/>
           </a:xfrm>
           <a:prstGeom prst="roundRect">
@@ -3238,7 +3238,7 @@
         </p:nvSpPr>
         <p:spPr>
           <a:xfrm>
-            <a:off x="8257123" y="4704314"/>
+            <a:off x="8257123" y="4544385"/>
             <a:ext cx="3395167" cy="182880"/>
           </a:xfrm>
           <a:prstGeom prst="rect">
@@ -3277,7 +3277,7 @@
         </p:nvSpPr>
         <p:spPr>
           <a:xfrm>
-            <a:off x="8257123" y="4925324"/>
+            <a:off x="8257123" y="4765396"/>
             <a:ext cx="3395167" cy="990204"/>
           </a:xfrm>
           <a:prstGeom prst="rect">
@@ -3389,7 +3389,7 @@
         </p:nvSpPr>
         <p:spPr>
           <a:xfrm>
-            <a:off x="8257123" y="5953658"/>
+            <a:off x="8257123" y="5793638"/>
             <a:ext cx="3395167" cy="198059"/>
           </a:xfrm>
           <a:prstGeom prst="rect">

</xml_diff>